<commit_message>
add image for ROS 2
</commit_message>
<xml_diff>
--- a/images/layered_scheme.pptx
+++ b/images/layered_scheme.pptx
@@ -6,6 +6,9 @@
   </p:sldMasterIdLst>
   <p:sldIdLst>
     <p:sldId id="256" r:id="rId2"/>
+    <p:sldId id="257" r:id="rId3"/>
+    <p:sldId id="258" r:id="rId4"/>
+    <p:sldId id="259" r:id="rId5"/>
   </p:sldIdLst>
   <p:sldSz cx="12192000" cy="6858000"/>
   <p:notesSz cx="6858000" cy="9144000"/>
@@ -104,6 +107,11 @@
       </a:defRPr>
     </a:lvl9pPr>
   </p:defaultTextStyle>
+  <p:extLst>
+    <p:ext uri="{EFAFB233-063F-42B5-8137-9DF3F51BA10A}">
+      <p15:sldGuideLst xmlns:p15="http://schemas.microsoft.com/office/powerpoint/2012/main"/>
+    </p:ext>
+  </p:extLst>
 </p:presentation>
 </file>
 
@@ -254,7 +262,7 @@
           <a:p>
             <a:fld id="{4255A406-218B-453C-8604-8324E45B3A14}" type="datetimeFigureOut">
               <a:rPr kumimoji="1" lang="ja-JP" altLang="en-US" smtClean="0"/>
-              <a:t>2019/12/23</a:t>
+              <a:t>2024/10/31</a:t>
             </a:fld>
             <a:endParaRPr kumimoji="1" lang="ja-JP" altLang="en-US"/>
           </a:p>
@@ -484,7 +492,7 @@
           <a:p>
             <a:fld id="{4255A406-218B-453C-8604-8324E45B3A14}" type="datetimeFigureOut">
               <a:rPr kumimoji="1" lang="ja-JP" altLang="en-US" smtClean="0"/>
-              <a:t>2019/12/23</a:t>
+              <a:t>2024/10/31</a:t>
             </a:fld>
             <a:endParaRPr kumimoji="1" lang="ja-JP" altLang="en-US"/>
           </a:p>
@@ -724,7 +732,7 @@
           <a:p>
             <a:fld id="{4255A406-218B-453C-8604-8324E45B3A14}" type="datetimeFigureOut">
               <a:rPr kumimoji="1" lang="ja-JP" altLang="en-US" smtClean="0"/>
-              <a:t>2019/12/23</a:t>
+              <a:t>2024/10/31</a:t>
             </a:fld>
             <a:endParaRPr kumimoji="1" lang="ja-JP" altLang="en-US"/>
           </a:p>
@@ -954,7 +962,7 @@
           <a:p>
             <a:fld id="{4255A406-218B-453C-8604-8324E45B3A14}" type="datetimeFigureOut">
               <a:rPr kumimoji="1" lang="ja-JP" altLang="en-US" smtClean="0"/>
-              <a:t>2019/12/23</a:t>
+              <a:t>2024/10/31</a:t>
             </a:fld>
             <a:endParaRPr kumimoji="1" lang="ja-JP" altLang="en-US"/>
           </a:p>
@@ -1229,7 +1237,7 @@
           <a:p>
             <a:fld id="{4255A406-218B-453C-8604-8324E45B3A14}" type="datetimeFigureOut">
               <a:rPr kumimoji="1" lang="ja-JP" altLang="en-US" smtClean="0"/>
-              <a:t>2019/12/23</a:t>
+              <a:t>2024/10/31</a:t>
             </a:fld>
             <a:endParaRPr kumimoji="1" lang="ja-JP" altLang="en-US"/>
           </a:p>
@@ -1558,7 +1566,7 @@
           <a:p>
             <a:fld id="{4255A406-218B-453C-8604-8324E45B3A14}" type="datetimeFigureOut">
               <a:rPr kumimoji="1" lang="ja-JP" altLang="en-US" smtClean="0"/>
-              <a:t>2019/12/23</a:t>
+              <a:t>2024/10/31</a:t>
             </a:fld>
             <a:endParaRPr kumimoji="1" lang="ja-JP" altLang="en-US"/>
           </a:p>
@@ -2034,7 +2042,7 @@
           <a:p>
             <a:fld id="{4255A406-218B-453C-8604-8324E45B3A14}" type="datetimeFigureOut">
               <a:rPr kumimoji="1" lang="ja-JP" altLang="en-US" smtClean="0"/>
-              <a:t>2019/12/23</a:t>
+              <a:t>2024/10/31</a:t>
             </a:fld>
             <a:endParaRPr kumimoji="1" lang="ja-JP" altLang="en-US"/>
           </a:p>
@@ -2175,7 +2183,7 @@
           <a:p>
             <a:fld id="{4255A406-218B-453C-8604-8324E45B3A14}" type="datetimeFigureOut">
               <a:rPr kumimoji="1" lang="ja-JP" altLang="en-US" smtClean="0"/>
-              <a:t>2019/12/23</a:t>
+              <a:t>2024/10/31</a:t>
             </a:fld>
             <a:endParaRPr kumimoji="1" lang="ja-JP" altLang="en-US"/>
           </a:p>
@@ -2288,7 +2296,7 @@
           <a:p>
             <a:fld id="{4255A406-218B-453C-8604-8324E45B3A14}" type="datetimeFigureOut">
               <a:rPr kumimoji="1" lang="ja-JP" altLang="en-US" smtClean="0"/>
-              <a:t>2019/12/23</a:t>
+              <a:t>2024/10/31</a:t>
             </a:fld>
             <a:endParaRPr kumimoji="1" lang="ja-JP" altLang="en-US"/>
           </a:p>
@@ -2631,7 +2639,7 @@
           <a:p>
             <a:fld id="{4255A406-218B-453C-8604-8324E45B3A14}" type="datetimeFigureOut">
               <a:rPr kumimoji="1" lang="ja-JP" altLang="en-US" smtClean="0"/>
-              <a:t>2019/12/23</a:t>
+              <a:t>2024/10/31</a:t>
             </a:fld>
             <a:endParaRPr kumimoji="1" lang="ja-JP" altLang="en-US"/>
           </a:p>
@@ -2919,7 +2927,7 @@
           <a:p>
             <a:fld id="{4255A406-218B-453C-8604-8324E45B3A14}" type="datetimeFigureOut">
               <a:rPr kumimoji="1" lang="ja-JP" altLang="en-US" smtClean="0"/>
-              <a:t>2019/12/23</a:t>
+              <a:t>2024/10/31</a:t>
             </a:fld>
             <a:endParaRPr kumimoji="1" lang="ja-JP" altLang="en-US"/>
           </a:p>
@@ -3192,7 +3200,7 @@
           <a:p>
             <a:fld id="{4255A406-218B-453C-8604-8324E45B3A14}" type="datetimeFigureOut">
               <a:rPr kumimoji="1" lang="ja-JP" altLang="en-US" smtClean="0"/>
-              <a:t>2019/12/23</a:t>
+              <a:t>2024/10/31</a:t>
             </a:fld>
             <a:endParaRPr kumimoji="1" lang="ja-JP" altLang="en-US"/>
           </a:p>
@@ -4611,6 +4619,3394 @@
 </p:sld>
 </file>
 
+<file path=ppt/slides/slide2.xml><?xml version="1.0" encoding="utf-8"?>
+<p:sld xmlns:a="http://schemas.openxmlformats.org/drawingml/2006/main" xmlns:r="http://schemas.openxmlformats.org/officeDocument/2006/relationships" xmlns:p="http://schemas.openxmlformats.org/presentationml/2006/main">
+  <p:cSld>
+    <p:spTree>
+      <p:nvGrpSpPr>
+        <p:cNvPr id="1" name=""/>
+        <p:cNvGrpSpPr/>
+        <p:nvPr/>
+      </p:nvGrpSpPr>
+      <p:grpSpPr>
+        <a:xfrm>
+          <a:off x="0" y="0"/>
+          <a:ext cx="0" cy="0"/>
+          <a:chOff x="0" y="0"/>
+          <a:chExt cx="0" cy="0"/>
+        </a:xfrm>
+      </p:grpSpPr>
+      <p:grpSp>
+        <p:nvGrpSpPr>
+          <p:cNvPr id="2" name="グループ化 1">
+            <a:extLst>
+              <a:ext uri="{FF2B5EF4-FFF2-40B4-BE49-F238E27FC236}">
+                <a16:creationId xmlns:a16="http://schemas.microsoft.com/office/drawing/2014/main" id="{DA953D4E-7FD3-438C-8646-F3097844EADF}"/>
+              </a:ext>
+            </a:extLst>
+          </p:cNvPr>
+          <p:cNvGrpSpPr/>
+          <p:nvPr/>
+        </p:nvGrpSpPr>
+        <p:grpSpPr>
+          <a:xfrm>
+            <a:off x="1223115" y="585788"/>
+            <a:ext cx="9983514" cy="5147444"/>
+            <a:chOff x="1223115" y="585788"/>
+            <a:chExt cx="9983514" cy="5147444"/>
+          </a:xfrm>
+        </p:grpSpPr>
+        <p:sp>
+          <p:nvSpPr>
+            <p:cNvPr id="4" name="正方形/長方形 3">
+              <a:extLst>
+                <a:ext uri="{FF2B5EF4-FFF2-40B4-BE49-F238E27FC236}">
+                  <a16:creationId xmlns:a16="http://schemas.microsoft.com/office/drawing/2014/main" id="{E2783359-64CA-4288-9C73-B05C7D063285}"/>
+                </a:ext>
+              </a:extLst>
+            </p:cNvPr>
+            <p:cNvSpPr/>
+            <p:nvPr/>
+          </p:nvSpPr>
+          <p:spPr>
+            <a:xfrm>
+              <a:off x="1223115" y="585788"/>
+              <a:ext cx="4986951" cy="5147444"/>
+            </a:xfrm>
+            <a:prstGeom prst="rect">
+              <a:avLst/>
+            </a:prstGeom>
+            <a:noFill/>
+            <a:ln w="19050">
+              <a:solidFill>
+                <a:schemeClr val="tx1"/>
+              </a:solidFill>
+            </a:ln>
+          </p:spPr>
+          <p:style>
+            <a:lnRef idx="2">
+              <a:schemeClr val="accent1">
+                <a:shade val="50000"/>
+              </a:schemeClr>
+            </a:lnRef>
+            <a:fillRef idx="1">
+              <a:schemeClr val="accent1"/>
+            </a:fillRef>
+            <a:effectRef idx="0">
+              <a:schemeClr val="accent1"/>
+            </a:effectRef>
+            <a:fontRef idx="minor">
+              <a:schemeClr val="lt1"/>
+            </a:fontRef>
+          </p:style>
+          <p:txBody>
+            <a:bodyPr rtlCol="0" anchor="ctr"/>
+            <a:lstStyle/>
+            <a:p>
+              <a:pPr algn="ctr"/>
+              <a:endParaRPr kumimoji="1" lang="ja-JP" altLang="en-US"/>
+            </a:p>
+          </p:txBody>
+        </p:sp>
+        <p:sp>
+          <p:nvSpPr>
+            <p:cNvPr id="5" name="テキスト ボックス 4">
+              <a:extLst>
+                <a:ext uri="{FF2B5EF4-FFF2-40B4-BE49-F238E27FC236}">
+                  <a16:creationId xmlns:a16="http://schemas.microsoft.com/office/drawing/2014/main" id="{74B68C2D-5E83-4D32-8699-B6AD8A66B7DF}"/>
+                </a:ext>
+              </a:extLst>
+            </p:cNvPr>
+            <p:cNvSpPr txBox="1"/>
+            <p:nvPr/>
+          </p:nvSpPr>
+          <p:spPr>
+            <a:xfrm flipH="1">
+              <a:off x="1307927" y="656347"/>
+              <a:ext cx="4425305" cy="369332"/>
+            </a:xfrm>
+            <a:prstGeom prst="rect">
+              <a:avLst/>
+            </a:prstGeom>
+            <a:noFill/>
+          </p:spPr>
+          <p:txBody>
+            <a:bodyPr wrap="square" rtlCol="0">
+              <a:spAutoFit/>
+            </a:bodyPr>
+            <a:lstStyle/>
+            <a:p>
+              <a:r>
+                <a:rPr lang="en-US" altLang="ja-JP" dirty="0" err="1">
+                  <a:latin typeface="Consolas" panose="020B0609020204030204" pitchFamily="49" charset="0"/>
+                </a:rPr>
+                <a:t>example_l</a:t>
+              </a:r>
+              <a:r>
+                <a:rPr kumimoji="1" lang="en-US" altLang="ja-JP" dirty="0" err="1">
+                  <a:latin typeface="Consolas" panose="020B0609020204030204" pitchFamily="49" charset="0"/>
+                </a:rPr>
+                <a:t>ayered_hardware_node</a:t>
+              </a:r>
+              <a:endParaRPr kumimoji="1" lang="ja-JP" altLang="en-US" dirty="0">
+                <a:latin typeface="Consolas" panose="020B0609020204030204" pitchFamily="49" charset="0"/>
+              </a:endParaRPr>
+            </a:p>
+          </p:txBody>
+        </p:sp>
+        <p:sp>
+          <p:nvSpPr>
+            <p:cNvPr id="6" name="テキスト ボックス 5">
+              <a:extLst>
+                <a:ext uri="{FF2B5EF4-FFF2-40B4-BE49-F238E27FC236}">
+                  <a16:creationId xmlns:a16="http://schemas.microsoft.com/office/drawing/2014/main" id="{03F2FECD-6AB2-477F-8A34-9C91ED6485F3}"/>
+                </a:ext>
+              </a:extLst>
+            </p:cNvPr>
+            <p:cNvSpPr txBox="1"/>
+            <p:nvPr/>
+          </p:nvSpPr>
+          <p:spPr>
+            <a:xfrm>
+              <a:off x="1769984" y="1346350"/>
+              <a:ext cx="3893212" cy="369332"/>
+            </a:xfrm>
+            <a:prstGeom prst="rect">
+              <a:avLst/>
+            </a:prstGeom>
+            <a:noFill/>
+            <a:ln>
+              <a:solidFill>
+                <a:schemeClr val="bg1">
+                  <a:lumMod val="65000"/>
+                </a:schemeClr>
+              </a:solidFill>
+            </a:ln>
+          </p:spPr>
+          <p:txBody>
+            <a:bodyPr wrap="square" rtlCol="0">
+              <a:spAutoFit/>
+            </a:bodyPr>
+            <a:lstStyle/>
+            <a:p>
+              <a:pPr algn="ctr"/>
+              <a:r>
+                <a:rPr kumimoji="1" lang="en-US" altLang="ja-JP" dirty="0" err="1">
+                  <a:latin typeface="Consolas" panose="020B0609020204030204" pitchFamily="49" charset="0"/>
+                </a:rPr>
+                <a:t>ControllerManager</a:t>
+              </a:r>
+              <a:endParaRPr kumimoji="1" lang="ja-JP" altLang="en-US" dirty="0">
+                <a:latin typeface="Consolas" panose="020B0609020204030204" pitchFamily="49" charset="0"/>
+              </a:endParaRPr>
+            </a:p>
+          </p:txBody>
+        </p:sp>
+        <p:sp>
+          <p:nvSpPr>
+            <p:cNvPr id="7" name="テキスト ボックス 6">
+              <a:extLst>
+                <a:ext uri="{FF2B5EF4-FFF2-40B4-BE49-F238E27FC236}">
+                  <a16:creationId xmlns:a16="http://schemas.microsoft.com/office/drawing/2014/main" id="{273FD731-FDFB-4B7C-BE6B-137C53B409A0}"/>
+                </a:ext>
+              </a:extLst>
+            </p:cNvPr>
+            <p:cNvSpPr txBox="1"/>
+            <p:nvPr/>
+          </p:nvSpPr>
+          <p:spPr>
+            <a:xfrm>
+              <a:off x="1769984" y="2244305"/>
+              <a:ext cx="3893212" cy="369332"/>
+            </a:xfrm>
+            <a:prstGeom prst="rect">
+              <a:avLst/>
+            </a:prstGeom>
+            <a:noFill/>
+            <a:ln w="28575">
+              <a:solidFill>
+                <a:schemeClr val="tx1"/>
+              </a:solidFill>
+            </a:ln>
+          </p:spPr>
+          <p:txBody>
+            <a:bodyPr wrap="square" rtlCol="0">
+              <a:spAutoFit/>
+            </a:bodyPr>
+            <a:lstStyle/>
+            <a:p>
+              <a:pPr algn="ctr"/>
+              <a:r>
+                <a:rPr lang="en-US" altLang="ja-JP" dirty="0" err="1">
+                  <a:latin typeface="Consolas" panose="020B0609020204030204" pitchFamily="49" charset="0"/>
+                </a:rPr>
+                <a:t>joint_limits_layer</a:t>
+              </a:r>
+              <a:endParaRPr kumimoji="1" lang="ja-JP" altLang="en-US" sz="1200" dirty="0">
+                <a:latin typeface="Georgia" panose="02040502050405020303" pitchFamily="18" charset="0"/>
+              </a:endParaRPr>
+            </a:p>
+          </p:txBody>
+        </p:sp>
+        <p:sp>
+          <p:nvSpPr>
+            <p:cNvPr id="8" name="テキスト ボックス 7">
+              <a:extLst>
+                <a:ext uri="{FF2B5EF4-FFF2-40B4-BE49-F238E27FC236}">
+                  <a16:creationId xmlns:a16="http://schemas.microsoft.com/office/drawing/2014/main" id="{7BE997F3-C491-47B8-8230-8C3D89A49DC8}"/>
+                </a:ext>
+              </a:extLst>
+            </p:cNvPr>
+            <p:cNvSpPr txBox="1"/>
+            <p:nvPr/>
+          </p:nvSpPr>
+          <p:spPr>
+            <a:xfrm>
+              <a:off x="1769984" y="3153016"/>
+              <a:ext cx="3893212" cy="369332"/>
+            </a:xfrm>
+            <a:prstGeom prst="rect">
+              <a:avLst/>
+            </a:prstGeom>
+            <a:noFill/>
+            <a:ln w="28575">
+              <a:solidFill>
+                <a:schemeClr val="tx1"/>
+              </a:solidFill>
+            </a:ln>
+          </p:spPr>
+          <p:txBody>
+            <a:bodyPr wrap="square" rtlCol="0">
+              <a:spAutoFit/>
+            </a:bodyPr>
+            <a:lstStyle/>
+            <a:p>
+              <a:pPr algn="ctr"/>
+              <a:r>
+                <a:rPr lang="en-US" altLang="ja-JP" dirty="0" err="1">
+                  <a:latin typeface="Consolas" panose="020B0609020204030204" pitchFamily="49" charset="0"/>
+                </a:rPr>
+                <a:t>transmission_layer</a:t>
+              </a:r>
+              <a:endParaRPr lang="en-US" altLang="ja-JP" dirty="0">
+                <a:latin typeface="Consolas" panose="020B0609020204030204" pitchFamily="49" charset="0"/>
+              </a:endParaRPr>
+            </a:p>
+          </p:txBody>
+        </p:sp>
+        <p:sp>
+          <p:nvSpPr>
+            <p:cNvPr id="9" name="テキスト ボックス 8">
+              <a:extLst>
+                <a:ext uri="{FF2B5EF4-FFF2-40B4-BE49-F238E27FC236}">
+                  <a16:creationId xmlns:a16="http://schemas.microsoft.com/office/drawing/2014/main" id="{8AF34787-1E64-424C-AC24-D2FB4ABC6567}"/>
+                </a:ext>
+              </a:extLst>
+            </p:cNvPr>
+            <p:cNvSpPr txBox="1"/>
+            <p:nvPr/>
+          </p:nvSpPr>
+          <p:spPr>
+            <a:xfrm>
+              <a:off x="1769984" y="4069914"/>
+              <a:ext cx="3893212" cy="369332"/>
+            </a:xfrm>
+            <a:prstGeom prst="rect">
+              <a:avLst/>
+            </a:prstGeom>
+            <a:noFill/>
+            <a:ln w="28575">
+              <a:solidFill>
+                <a:schemeClr val="tx1"/>
+              </a:solidFill>
+            </a:ln>
+          </p:spPr>
+          <p:txBody>
+            <a:bodyPr wrap="square" rtlCol="0">
+              <a:spAutoFit/>
+            </a:bodyPr>
+            <a:lstStyle/>
+            <a:p>
+              <a:pPr algn="ctr"/>
+              <a:r>
+                <a:rPr lang="en-US" altLang="ja-JP" dirty="0" err="1">
+                  <a:latin typeface="Consolas" panose="020B0609020204030204" pitchFamily="49" charset="0"/>
+                </a:rPr>
+                <a:t>position_actuator_layer</a:t>
+              </a:r>
+              <a:endParaRPr lang="en-US" altLang="ja-JP" dirty="0">
+                <a:latin typeface="Consolas" panose="020B0609020204030204" pitchFamily="49" charset="0"/>
+              </a:endParaRPr>
+            </a:p>
+          </p:txBody>
+        </p:sp>
+        <p:cxnSp>
+          <p:nvCxnSpPr>
+            <p:cNvPr id="11" name="直線矢印コネクタ 10">
+              <a:extLst>
+                <a:ext uri="{FF2B5EF4-FFF2-40B4-BE49-F238E27FC236}">
+                  <a16:creationId xmlns:a16="http://schemas.microsoft.com/office/drawing/2014/main" id="{30E704C7-38DA-4280-93EA-4AE5D43825EB}"/>
+                </a:ext>
+              </a:extLst>
+            </p:cNvPr>
+            <p:cNvCxnSpPr/>
+            <p:nvPr/>
+          </p:nvCxnSpPr>
+          <p:spPr>
+            <a:xfrm>
+              <a:off x="4315438" y="1715682"/>
+              <a:ext cx="0" cy="528623"/>
+            </a:xfrm>
+            <a:prstGeom prst="straightConnector1">
+              <a:avLst/>
+            </a:prstGeom>
+            <a:ln w="19050">
+              <a:solidFill>
+                <a:schemeClr val="tx1"/>
+              </a:solidFill>
+              <a:tailEnd type="triangle" w="lg" len="med"/>
+            </a:ln>
+          </p:spPr>
+          <p:style>
+            <a:lnRef idx="1">
+              <a:schemeClr val="accent1"/>
+            </a:lnRef>
+            <a:fillRef idx="0">
+              <a:schemeClr val="accent1"/>
+            </a:fillRef>
+            <a:effectRef idx="0">
+              <a:schemeClr val="accent1"/>
+            </a:effectRef>
+            <a:fontRef idx="minor">
+              <a:schemeClr val="tx1"/>
+            </a:fontRef>
+          </p:style>
+        </p:cxnSp>
+        <p:cxnSp>
+          <p:nvCxnSpPr>
+            <p:cNvPr id="12" name="直線矢印コネクタ 11">
+              <a:extLst>
+                <a:ext uri="{FF2B5EF4-FFF2-40B4-BE49-F238E27FC236}">
+                  <a16:creationId xmlns:a16="http://schemas.microsoft.com/office/drawing/2014/main" id="{499CB9A0-4A4D-4698-9A5A-A31B8F2B310C}"/>
+                </a:ext>
+              </a:extLst>
+            </p:cNvPr>
+            <p:cNvCxnSpPr/>
+            <p:nvPr/>
+          </p:nvCxnSpPr>
+          <p:spPr>
+            <a:xfrm>
+              <a:off x="4315438" y="2624393"/>
+              <a:ext cx="0" cy="528623"/>
+            </a:xfrm>
+            <a:prstGeom prst="straightConnector1">
+              <a:avLst/>
+            </a:prstGeom>
+            <a:ln w="19050">
+              <a:solidFill>
+                <a:schemeClr val="tx1"/>
+              </a:solidFill>
+              <a:tailEnd type="triangle" w="lg" len="med"/>
+            </a:ln>
+          </p:spPr>
+          <p:style>
+            <a:lnRef idx="1">
+              <a:schemeClr val="accent1"/>
+            </a:lnRef>
+            <a:fillRef idx="0">
+              <a:schemeClr val="accent1"/>
+            </a:fillRef>
+            <a:effectRef idx="0">
+              <a:schemeClr val="accent1"/>
+            </a:effectRef>
+            <a:fontRef idx="minor">
+              <a:schemeClr val="tx1"/>
+            </a:fontRef>
+          </p:style>
+        </p:cxnSp>
+        <p:cxnSp>
+          <p:nvCxnSpPr>
+            <p:cNvPr id="13" name="直線矢印コネクタ 12">
+              <a:extLst>
+                <a:ext uri="{FF2B5EF4-FFF2-40B4-BE49-F238E27FC236}">
+                  <a16:creationId xmlns:a16="http://schemas.microsoft.com/office/drawing/2014/main" id="{61E7681E-6EE9-4027-BEE9-973B58890744}"/>
+                </a:ext>
+              </a:extLst>
+            </p:cNvPr>
+            <p:cNvCxnSpPr/>
+            <p:nvPr/>
+          </p:nvCxnSpPr>
+          <p:spPr>
+            <a:xfrm>
+              <a:off x="4321983" y="3533108"/>
+              <a:ext cx="0" cy="528623"/>
+            </a:xfrm>
+            <a:prstGeom prst="straightConnector1">
+              <a:avLst/>
+            </a:prstGeom>
+            <a:ln w="19050">
+              <a:solidFill>
+                <a:schemeClr val="tx1"/>
+              </a:solidFill>
+              <a:tailEnd type="triangle" w="lg" len="med"/>
+            </a:ln>
+          </p:spPr>
+          <p:style>
+            <a:lnRef idx="1">
+              <a:schemeClr val="accent1"/>
+            </a:lnRef>
+            <a:fillRef idx="0">
+              <a:schemeClr val="accent1"/>
+            </a:fillRef>
+            <a:effectRef idx="0">
+              <a:schemeClr val="accent1"/>
+            </a:effectRef>
+            <a:fontRef idx="minor">
+              <a:schemeClr val="tx1"/>
+            </a:fontRef>
+          </p:style>
+        </p:cxnSp>
+        <p:cxnSp>
+          <p:nvCxnSpPr>
+            <p:cNvPr id="14" name="直線矢印コネクタ 13">
+              <a:extLst>
+                <a:ext uri="{FF2B5EF4-FFF2-40B4-BE49-F238E27FC236}">
+                  <a16:creationId xmlns:a16="http://schemas.microsoft.com/office/drawing/2014/main" id="{5BDA5ECC-2AA9-4748-8018-AEABFE402207}"/>
+                </a:ext>
+              </a:extLst>
+            </p:cNvPr>
+            <p:cNvCxnSpPr>
+              <a:cxnSpLocks/>
+            </p:cNvCxnSpPr>
+            <p:nvPr/>
+          </p:nvCxnSpPr>
+          <p:spPr>
+            <a:xfrm flipV="1">
+              <a:off x="3111198" y="3533108"/>
+              <a:ext cx="0" cy="528623"/>
+            </a:xfrm>
+            <a:prstGeom prst="straightConnector1">
+              <a:avLst/>
+            </a:prstGeom>
+            <a:ln w="19050">
+              <a:solidFill>
+                <a:schemeClr val="tx1"/>
+              </a:solidFill>
+              <a:tailEnd type="triangle" w="lg" len="med"/>
+            </a:ln>
+          </p:spPr>
+          <p:style>
+            <a:lnRef idx="1">
+              <a:schemeClr val="accent1"/>
+            </a:lnRef>
+            <a:fillRef idx="0">
+              <a:schemeClr val="accent1"/>
+            </a:fillRef>
+            <a:effectRef idx="0">
+              <a:schemeClr val="accent1"/>
+            </a:effectRef>
+            <a:fontRef idx="minor">
+              <a:schemeClr val="tx1"/>
+            </a:fontRef>
+          </p:style>
+        </p:cxnSp>
+        <p:cxnSp>
+          <p:nvCxnSpPr>
+            <p:cNvPr id="15" name="直線矢印コネクタ 14">
+              <a:extLst>
+                <a:ext uri="{FF2B5EF4-FFF2-40B4-BE49-F238E27FC236}">
+                  <a16:creationId xmlns:a16="http://schemas.microsoft.com/office/drawing/2014/main" id="{3133D3B5-441E-420F-8516-5A2E66137F71}"/>
+                </a:ext>
+              </a:extLst>
+            </p:cNvPr>
+            <p:cNvCxnSpPr>
+              <a:cxnSpLocks/>
+            </p:cNvCxnSpPr>
+            <p:nvPr/>
+          </p:nvCxnSpPr>
+          <p:spPr>
+            <a:xfrm flipV="1">
+              <a:off x="3111198" y="2624393"/>
+              <a:ext cx="0" cy="528623"/>
+            </a:xfrm>
+            <a:prstGeom prst="straightConnector1">
+              <a:avLst/>
+            </a:prstGeom>
+            <a:ln w="19050">
+              <a:solidFill>
+                <a:schemeClr val="tx1"/>
+              </a:solidFill>
+              <a:tailEnd type="triangle" w="lg" len="med"/>
+            </a:ln>
+          </p:spPr>
+          <p:style>
+            <a:lnRef idx="1">
+              <a:schemeClr val="accent1"/>
+            </a:lnRef>
+            <a:fillRef idx="0">
+              <a:schemeClr val="accent1"/>
+            </a:fillRef>
+            <a:effectRef idx="0">
+              <a:schemeClr val="accent1"/>
+            </a:effectRef>
+            <a:fontRef idx="minor">
+              <a:schemeClr val="tx1"/>
+            </a:fontRef>
+          </p:style>
+        </p:cxnSp>
+        <p:cxnSp>
+          <p:nvCxnSpPr>
+            <p:cNvPr id="16" name="直線矢印コネクタ 15">
+              <a:extLst>
+                <a:ext uri="{FF2B5EF4-FFF2-40B4-BE49-F238E27FC236}">
+                  <a16:creationId xmlns:a16="http://schemas.microsoft.com/office/drawing/2014/main" id="{01400E0B-4FC1-4839-A89A-B91138FD9A7F}"/>
+                </a:ext>
+              </a:extLst>
+            </p:cNvPr>
+            <p:cNvCxnSpPr>
+              <a:cxnSpLocks/>
+            </p:cNvCxnSpPr>
+            <p:nvPr/>
+          </p:nvCxnSpPr>
+          <p:spPr>
+            <a:xfrm flipV="1">
+              <a:off x="3111198" y="1715682"/>
+              <a:ext cx="0" cy="528623"/>
+            </a:xfrm>
+            <a:prstGeom prst="straightConnector1">
+              <a:avLst/>
+            </a:prstGeom>
+            <a:ln w="19050">
+              <a:solidFill>
+                <a:schemeClr val="tx1"/>
+              </a:solidFill>
+              <a:tailEnd type="triangle" w="lg" len="med"/>
+            </a:ln>
+          </p:spPr>
+          <p:style>
+            <a:lnRef idx="1">
+              <a:schemeClr val="accent1"/>
+            </a:lnRef>
+            <a:fillRef idx="0">
+              <a:schemeClr val="accent1"/>
+            </a:fillRef>
+            <a:effectRef idx="0">
+              <a:schemeClr val="accent1"/>
+            </a:effectRef>
+            <a:fontRef idx="minor">
+              <a:schemeClr val="tx1"/>
+            </a:fontRef>
+          </p:style>
+        </p:cxnSp>
+        <p:sp>
+          <p:nvSpPr>
+            <p:cNvPr id="22" name="テキスト ボックス 21">
+              <a:extLst>
+                <a:ext uri="{FF2B5EF4-FFF2-40B4-BE49-F238E27FC236}">
+                  <a16:creationId xmlns:a16="http://schemas.microsoft.com/office/drawing/2014/main" id="{E8002B43-C55C-4E30-A311-F4CC90EC0513}"/>
+                </a:ext>
+              </a:extLst>
+            </p:cNvPr>
+            <p:cNvSpPr txBox="1"/>
+            <p:nvPr/>
+          </p:nvSpPr>
+          <p:spPr>
+            <a:xfrm>
+              <a:off x="8027645" y="1346350"/>
+              <a:ext cx="3178983" cy="369332"/>
+            </a:xfrm>
+            <a:prstGeom prst="rect">
+              <a:avLst/>
+            </a:prstGeom>
+            <a:noFill/>
+            <a:ln>
+              <a:solidFill>
+                <a:schemeClr val="bg1">
+                  <a:lumMod val="65000"/>
+                </a:schemeClr>
+              </a:solidFill>
+            </a:ln>
+          </p:spPr>
+          <p:txBody>
+            <a:bodyPr wrap="square" rtlCol="0">
+              <a:spAutoFit/>
+            </a:bodyPr>
+            <a:lstStyle/>
+            <a:p>
+              <a:pPr algn="ctr"/>
+              <a:r>
+                <a:rPr kumimoji="1" lang="en-US" altLang="ja-JP" dirty="0">
+                  <a:latin typeface="Consolas" panose="020B0609020204030204" pitchFamily="49" charset="0"/>
+                </a:rPr>
+                <a:t>User ROS nodes</a:t>
+              </a:r>
+              <a:endParaRPr kumimoji="1" lang="ja-JP" altLang="en-US" dirty="0">
+                <a:latin typeface="Consolas" panose="020B0609020204030204" pitchFamily="49" charset="0"/>
+              </a:endParaRPr>
+            </a:p>
+          </p:txBody>
+        </p:sp>
+        <p:sp>
+          <p:nvSpPr>
+            <p:cNvPr id="23" name="テキスト ボックス 22">
+              <a:extLst>
+                <a:ext uri="{FF2B5EF4-FFF2-40B4-BE49-F238E27FC236}">
+                  <a16:creationId xmlns:a16="http://schemas.microsoft.com/office/drawing/2014/main" id="{76F211D6-BB3F-45FC-8FD6-FF7E676E34EA}"/>
+                </a:ext>
+              </a:extLst>
+            </p:cNvPr>
+            <p:cNvSpPr txBox="1"/>
+            <p:nvPr/>
+          </p:nvSpPr>
+          <p:spPr>
+            <a:xfrm>
+              <a:off x="8027645" y="3977581"/>
+              <a:ext cx="3178984" cy="553998"/>
+            </a:xfrm>
+            <a:prstGeom prst="rect">
+              <a:avLst/>
+            </a:prstGeom>
+            <a:noFill/>
+            <a:ln>
+              <a:solidFill>
+                <a:schemeClr val="bg1">
+                  <a:lumMod val="65000"/>
+                </a:schemeClr>
+              </a:solidFill>
+            </a:ln>
+          </p:spPr>
+          <p:txBody>
+            <a:bodyPr wrap="square" rtlCol="0" anchor="ctr" anchorCtr="0">
+              <a:noAutofit/>
+            </a:bodyPr>
+            <a:lstStyle/>
+            <a:p>
+              <a:pPr algn="ctr"/>
+              <a:r>
+                <a:rPr lang="en-US" altLang="ja-JP" dirty="0" err="1">
+                  <a:latin typeface="Consolas" panose="020B0609020204030204" pitchFamily="49" charset="0"/>
+                </a:rPr>
+                <a:t>Positon</a:t>
+              </a:r>
+              <a:r>
+                <a:rPr lang="en-US" altLang="ja-JP" dirty="0">
+                  <a:latin typeface="Consolas" panose="020B0609020204030204" pitchFamily="49" charset="0"/>
+                </a:rPr>
+                <a:t>-controlled</a:t>
+              </a:r>
+              <a:br>
+                <a:rPr lang="en-US" altLang="ja-JP" dirty="0">
+                  <a:latin typeface="Consolas" panose="020B0609020204030204" pitchFamily="49" charset="0"/>
+                </a:rPr>
+              </a:br>
+              <a:r>
+                <a:rPr lang="en-US" altLang="ja-JP" dirty="0">
+                  <a:latin typeface="Consolas" panose="020B0609020204030204" pitchFamily="49" charset="0"/>
+                </a:rPr>
+                <a:t>actuator hardware</a:t>
+              </a:r>
+              <a:endParaRPr kumimoji="1" lang="ja-JP" altLang="en-US" dirty="0">
+                <a:latin typeface="Consolas" panose="020B0609020204030204" pitchFamily="49" charset="0"/>
+              </a:endParaRPr>
+            </a:p>
+          </p:txBody>
+        </p:sp>
+        <p:cxnSp>
+          <p:nvCxnSpPr>
+            <p:cNvPr id="25" name="直線矢印コネクタ 24">
+              <a:extLst>
+                <a:ext uri="{FF2B5EF4-FFF2-40B4-BE49-F238E27FC236}">
+                  <a16:creationId xmlns:a16="http://schemas.microsoft.com/office/drawing/2014/main" id="{8B24F9DF-C399-49D8-BB87-6F78794A1655}"/>
+                </a:ext>
+              </a:extLst>
+            </p:cNvPr>
+            <p:cNvCxnSpPr>
+              <a:cxnSpLocks/>
+              <a:stCxn id="6" idx="3"/>
+              <a:endCxn id="22" idx="1"/>
+            </p:cNvCxnSpPr>
+            <p:nvPr/>
+          </p:nvCxnSpPr>
+          <p:spPr>
+            <a:xfrm>
+              <a:off x="5663196" y="1531016"/>
+              <a:ext cx="2364449" cy="0"/>
+            </a:xfrm>
+            <a:prstGeom prst="straightConnector1">
+              <a:avLst/>
+            </a:prstGeom>
+            <a:ln w="19050">
+              <a:solidFill>
+                <a:schemeClr val="tx1"/>
+              </a:solidFill>
+              <a:headEnd type="triangle" w="lg" len="med"/>
+              <a:tailEnd type="triangle" w="lg" len="med"/>
+            </a:ln>
+          </p:spPr>
+          <p:style>
+            <a:lnRef idx="1">
+              <a:schemeClr val="accent1"/>
+            </a:lnRef>
+            <a:fillRef idx="0">
+              <a:schemeClr val="accent1"/>
+            </a:fillRef>
+            <a:effectRef idx="0">
+              <a:schemeClr val="accent1"/>
+            </a:effectRef>
+            <a:fontRef idx="minor">
+              <a:schemeClr val="tx1"/>
+            </a:fontRef>
+          </p:style>
+        </p:cxnSp>
+        <p:cxnSp>
+          <p:nvCxnSpPr>
+            <p:cNvPr id="26" name="直線矢印コネクタ 25">
+              <a:extLst>
+                <a:ext uri="{FF2B5EF4-FFF2-40B4-BE49-F238E27FC236}">
+                  <a16:creationId xmlns:a16="http://schemas.microsoft.com/office/drawing/2014/main" id="{0BAF36BD-3B91-4F54-8505-2B3120018937}"/>
+                </a:ext>
+              </a:extLst>
+            </p:cNvPr>
+            <p:cNvCxnSpPr>
+              <a:cxnSpLocks/>
+              <a:stCxn id="9" idx="3"/>
+              <a:endCxn id="23" idx="1"/>
+            </p:cNvCxnSpPr>
+            <p:nvPr/>
+          </p:nvCxnSpPr>
+          <p:spPr>
+            <a:xfrm>
+              <a:off x="5663196" y="4254580"/>
+              <a:ext cx="2364449" cy="0"/>
+            </a:xfrm>
+            <a:prstGeom prst="straightConnector1">
+              <a:avLst/>
+            </a:prstGeom>
+            <a:ln w="19050">
+              <a:solidFill>
+                <a:schemeClr val="tx1"/>
+              </a:solidFill>
+              <a:headEnd type="triangle" w="lg" len="med"/>
+              <a:tailEnd type="triangle" w="lg" len="med"/>
+            </a:ln>
+          </p:spPr>
+          <p:style>
+            <a:lnRef idx="1">
+              <a:schemeClr val="accent1"/>
+            </a:lnRef>
+            <a:fillRef idx="0">
+              <a:schemeClr val="accent1"/>
+            </a:fillRef>
+            <a:effectRef idx="0">
+              <a:schemeClr val="accent1"/>
+            </a:effectRef>
+            <a:fontRef idx="minor">
+              <a:schemeClr val="tx1"/>
+            </a:fontRef>
+          </p:style>
+        </p:cxnSp>
+        <p:sp>
+          <p:nvSpPr>
+            <p:cNvPr id="29" name="テキスト ボックス 28">
+              <a:extLst>
+                <a:ext uri="{FF2B5EF4-FFF2-40B4-BE49-F238E27FC236}">
+                  <a16:creationId xmlns:a16="http://schemas.microsoft.com/office/drawing/2014/main" id="{CE2F09B5-FE64-4EE1-B358-AF6D05F6A1D0}"/>
+                </a:ext>
+              </a:extLst>
+            </p:cNvPr>
+            <p:cNvSpPr txBox="1"/>
+            <p:nvPr/>
+          </p:nvSpPr>
+          <p:spPr>
+            <a:xfrm>
+              <a:off x="6293196" y="790526"/>
+              <a:ext cx="2031769" cy="738664"/>
+            </a:xfrm>
+            <a:prstGeom prst="rect">
+              <a:avLst/>
+            </a:prstGeom>
+            <a:noFill/>
+          </p:spPr>
+          <p:txBody>
+            <a:bodyPr wrap="square" rtlCol="0">
+              <a:spAutoFit/>
+            </a:bodyPr>
+            <a:lstStyle/>
+            <a:p>
+              <a:r>
+                <a:rPr lang="en-US" altLang="ja-JP" sz="1400" dirty="0">
+                  <a:latin typeface="Georgia" panose="02040502050405020303" pitchFamily="18" charset="0"/>
+                </a:rPr>
+                <a:t>r</a:t>
+              </a:r>
+              <a:r>
+                <a:rPr kumimoji="1" lang="en-US" altLang="ja-JP" sz="1400" dirty="0">
+                  <a:latin typeface="Georgia" panose="02040502050405020303" pitchFamily="18" charset="0"/>
+                </a:rPr>
+                <a:t>ead states /</a:t>
+              </a:r>
+            </a:p>
+            <a:p>
+              <a:r>
+                <a:rPr kumimoji="1" lang="en-US" altLang="ja-JP" sz="1400" dirty="0">
+                  <a:latin typeface="Georgia" panose="02040502050405020303" pitchFamily="18" charset="0"/>
+                </a:rPr>
+                <a:t>write commands</a:t>
+              </a:r>
+              <a:br>
+                <a:rPr kumimoji="1" lang="en-US" altLang="ja-JP" sz="1400" dirty="0">
+                  <a:latin typeface="Georgia" panose="02040502050405020303" pitchFamily="18" charset="0"/>
+                </a:rPr>
+              </a:br>
+              <a:r>
+                <a:rPr kumimoji="1" lang="en-US" altLang="ja-JP" sz="1400" dirty="0">
+                  <a:latin typeface="Georgia" panose="02040502050405020303" pitchFamily="18" charset="0"/>
+                </a:rPr>
+                <a:t>via ROS messages</a:t>
+              </a:r>
+              <a:endParaRPr kumimoji="1" lang="ja-JP" altLang="en-US" sz="1400" dirty="0">
+                <a:latin typeface="Georgia" panose="02040502050405020303" pitchFamily="18" charset="0"/>
+              </a:endParaRPr>
+            </a:p>
+          </p:txBody>
+        </p:sp>
+        <p:sp>
+          <p:nvSpPr>
+            <p:cNvPr id="30" name="テキスト ボックス 29">
+              <a:extLst>
+                <a:ext uri="{FF2B5EF4-FFF2-40B4-BE49-F238E27FC236}">
+                  <a16:creationId xmlns:a16="http://schemas.microsoft.com/office/drawing/2014/main" id="{1D8140B8-12D3-4A04-B3D1-584D6C9BA7EF}"/>
+                </a:ext>
+              </a:extLst>
+            </p:cNvPr>
+            <p:cNvSpPr txBox="1"/>
+            <p:nvPr/>
+          </p:nvSpPr>
+          <p:spPr>
+            <a:xfrm>
+              <a:off x="6259537" y="3281202"/>
+              <a:ext cx="2364448" cy="954107"/>
+            </a:xfrm>
+            <a:prstGeom prst="rect">
+              <a:avLst/>
+            </a:prstGeom>
+            <a:noFill/>
+          </p:spPr>
+          <p:txBody>
+            <a:bodyPr wrap="square" rtlCol="0">
+              <a:spAutoFit/>
+            </a:bodyPr>
+            <a:lstStyle/>
+            <a:p>
+              <a:r>
+                <a:rPr kumimoji="1" lang="en-US" altLang="ja-JP" sz="1400" dirty="0">
+                  <a:latin typeface="Georgia" panose="02040502050405020303" pitchFamily="18" charset="0"/>
+                </a:rPr>
+                <a:t>read states /</a:t>
+              </a:r>
+              <a:br>
+                <a:rPr kumimoji="1" lang="en-US" altLang="ja-JP" sz="1400" dirty="0">
+                  <a:latin typeface="Georgia" panose="02040502050405020303" pitchFamily="18" charset="0"/>
+                </a:rPr>
+              </a:br>
+              <a:r>
+                <a:rPr kumimoji="1" lang="en-US" altLang="ja-JP" sz="1400" dirty="0">
+                  <a:latin typeface="Georgia" panose="02040502050405020303" pitchFamily="18" charset="0"/>
+                </a:rPr>
+                <a:t>write commands</a:t>
+              </a:r>
+              <a:br>
+                <a:rPr kumimoji="1" lang="en-US" altLang="ja-JP" sz="1400" dirty="0">
+                  <a:latin typeface="Georgia" panose="02040502050405020303" pitchFamily="18" charset="0"/>
+                </a:rPr>
+              </a:br>
+              <a:r>
+                <a:rPr kumimoji="1" lang="en-US" altLang="ja-JP" sz="1400" dirty="0">
+                  <a:latin typeface="Georgia" panose="02040502050405020303" pitchFamily="18" charset="0"/>
+                </a:rPr>
+                <a:t>via actuator-specific</a:t>
+              </a:r>
+              <a:br>
+                <a:rPr kumimoji="1" lang="en-US" altLang="ja-JP" sz="1400" dirty="0">
+                  <a:latin typeface="Georgia" panose="02040502050405020303" pitchFamily="18" charset="0"/>
+                </a:rPr>
+              </a:br>
+              <a:r>
+                <a:rPr kumimoji="1" lang="en-US" altLang="ja-JP" sz="1400" dirty="0">
+                  <a:latin typeface="Georgia" panose="02040502050405020303" pitchFamily="18" charset="0"/>
+                </a:rPr>
+                <a:t>interface</a:t>
+              </a:r>
+              <a:endParaRPr kumimoji="1" lang="ja-JP" altLang="en-US" sz="1400" dirty="0">
+                <a:latin typeface="Georgia" panose="02040502050405020303" pitchFamily="18" charset="0"/>
+              </a:endParaRPr>
+            </a:p>
+          </p:txBody>
+        </p:sp>
+        <p:sp>
+          <p:nvSpPr>
+            <p:cNvPr id="34" name="テキスト ボックス 33">
+              <a:extLst>
+                <a:ext uri="{FF2B5EF4-FFF2-40B4-BE49-F238E27FC236}">
+                  <a16:creationId xmlns:a16="http://schemas.microsoft.com/office/drawing/2014/main" id="{DF607E99-00F5-4690-96CD-7206F7A8797E}"/>
+                </a:ext>
+              </a:extLst>
+            </p:cNvPr>
+            <p:cNvSpPr txBox="1"/>
+            <p:nvPr/>
+          </p:nvSpPr>
+          <p:spPr>
+            <a:xfrm>
+              <a:off x="4328749" y="1828531"/>
+              <a:ext cx="680816" cy="307777"/>
+            </a:xfrm>
+            <a:prstGeom prst="rect">
+              <a:avLst/>
+            </a:prstGeom>
+            <a:noFill/>
+          </p:spPr>
+          <p:txBody>
+            <a:bodyPr wrap="square" rtlCol="0">
+              <a:spAutoFit/>
+            </a:bodyPr>
+            <a:lstStyle/>
+            <a:p>
+              <a:r>
+                <a:rPr kumimoji="1" lang="en-US" altLang="ja-JP" sz="1400" dirty="0">
+                  <a:latin typeface="Georgia" panose="02040502050405020303" pitchFamily="18" charset="0"/>
+                </a:rPr>
+                <a:t>write</a:t>
+              </a:r>
+              <a:endParaRPr kumimoji="1" lang="ja-JP" altLang="en-US" sz="1400" dirty="0">
+                <a:latin typeface="Georgia" panose="02040502050405020303" pitchFamily="18" charset="0"/>
+              </a:endParaRPr>
+            </a:p>
+          </p:txBody>
+        </p:sp>
+        <p:sp>
+          <p:nvSpPr>
+            <p:cNvPr id="35" name="テキスト ボックス 34">
+              <a:extLst>
+                <a:ext uri="{FF2B5EF4-FFF2-40B4-BE49-F238E27FC236}">
+                  <a16:creationId xmlns:a16="http://schemas.microsoft.com/office/drawing/2014/main" id="{9477A8B0-0A16-4C74-8A84-F14B132B678A}"/>
+                </a:ext>
+              </a:extLst>
+            </p:cNvPr>
+            <p:cNvSpPr txBox="1"/>
+            <p:nvPr/>
+          </p:nvSpPr>
+          <p:spPr>
+            <a:xfrm>
+              <a:off x="3113290" y="1823679"/>
+              <a:ext cx="680816" cy="307777"/>
+            </a:xfrm>
+            <a:prstGeom prst="rect">
+              <a:avLst/>
+            </a:prstGeom>
+            <a:noFill/>
+          </p:spPr>
+          <p:txBody>
+            <a:bodyPr wrap="square" rtlCol="0">
+              <a:spAutoFit/>
+            </a:bodyPr>
+            <a:lstStyle/>
+            <a:p>
+              <a:r>
+                <a:rPr lang="en-US" altLang="ja-JP" sz="1400" dirty="0">
+                  <a:latin typeface="Georgia" panose="02040502050405020303" pitchFamily="18" charset="0"/>
+                </a:rPr>
+                <a:t>r</a:t>
+              </a:r>
+              <a:r>
+                <a:rPr kumimoji="1" lang="en-US" altLang="ja-JP" sz="1400" dirty="0">
+                  <a:latin typeface="Georgia" panose="02040502050405020303" pitchFamily="18" charset="0"/>
+                </a:rPr>
+                <a:t>ead</a:t>
+              </a:r>
+              <a:endParaRPr kumimoji="1" lang="ja-JP" altLang="en-US" sz="1400" dirty="0">
+                <a:latin typeface="Georgia" panose="02040502050405020303" pitchFamily="18" charset="0"/>
+              </a:endParaRPr>
+            </a:p>
+          </p:txBody>
+        </p:sp>
+        <p:sp>
+          <p:nvSpPr>
+            <p:cNvPr id="24" name="テキスト ボックス 23">
+              <a:extLst>
+                <a:ext uri="{FF2B5EF4-FFF2-40B4-BE49-F238E27FC236}">
+                  <a16:creationId xmlns:a16="http://schemas.microsoft.com/office/drawing/2014/main" id="{63C282E4-962F-411F-9A42-11C4F8782399}"/>
+                </a:ext>
+              </a:extLst>
+            </p:cNvPr>
+            <p:cNvSpPr txBox="1"/>
+            <p:nvPr/>
+          </p:nvSpPr>
+          <p:spPr>
+            <a:xfrm>
+              <a:off x="1769983" y="4974071"/>
+              <a:ext cx="3893212" cy="369332"/>
+            </a:xfrm>
+            <a:prstGeom prst="rect">
+              <a:avLst/>
+            </a:prstGeom>
+            <a:noFill/>
+            <a:ln w="28575">
+              <a:solidFill>
+                <a:schemeClr val="tx1"/>
+              </a:solidFill>
+            </a:ln>
+          </p:spPr>
+          <p:txBody>
+            <a:bodyPr wrap="square" rtlCol="0">
+              <a:spAutoFit/>
+            </a:bodyPr>
+            <a:lstStyle/>
+            <a:p>
+              <a:pPr algn="ctr"/>
+              <a:r>
+                <a:rPr lang="en-US" altLang="ja-JP" dirty="0" err="1">
+                  <a:latin typeface="Consolas" panose="020B0609020204030204" pitchFamily="49" charset="0"/>
+                </a:rPr>
+                <a:t>effort_actuator_layer</a:t>
+              </a:r>
+              <a:endParaRPr lang="en-US" altLang="ja-JP" dirty="0">
+                <a:latin typeface="Consolas" panose="020B0609020204030204" pitchFamily="49" charset="0"/>
+              </a:endParaRPr>
+            </a:p>
+          </p:txBody>
+        </p:sp>
+        <p:sp>
+          <p:nvSpPr>
+            <p:cNvPr id="27" name="テキスト ボックス 26">
+              <a:extLst>
+                <a:ext uri="{FF2B5EF4-FFF2-40B4-BE49-F238E27FC236}">
+                  <a16:creationId xmlns:a16="http://schemas.microsoft.com/office/drawing/2014/main" id="{330FDCAC-ADFC-4FB8-80F7-6A7C2D9B0CFD}"/>
+                </a:ext>
+              </a:extLst>
+            </p:cNvPr>
+            <p:cNvSpPr txBox="1"/>
+            <p:nvPr/>
+          </p:nvSpPr>
+          <p:spPr>
+            <a:xfrm>
+              <a:off x="8027644" y="4881738"/>
+              <a:ext cx="3178984" cy="553998"/>
+            </a:xfrm>
+            <a:prstGeom prst="rect">
+              <a:avLst/>
+            </a:prstGeom>
+            <a:noFill/>
+            <a:ln>
+              <a:solidFill>
+                <a:schemeClr val="bg1">
+                  <a:lumMod val="65000"/>
+                </a:schemeClr>
+              </a:solidFill>
+            </a:ln>
+          </p:spPr>
+          <p:txBody>
+            <a:bodyPr wrap="square" rtlCol="0" anchor="ctr" anchorCtr="0">
+              <a:noAutofit/>
+            </a:bodyPr>
+            <a:lstStyle/>
+            <a:p>
+              <a:pPr algn="ctr"/>
+              <a:r>
+                <a:rPr lang="en-US" altLang="ja-JP" dirty="0">
+                  <a:latin typeface="Consolas" panose="020B0609020204030204" pitchFamily="49" charset="0"/>
+                </a:rPr>
+                <a:t>Effort-controlled</a:t>
+              </a:r>
+              <a:br>
+                <a:rPr lang="en-US" altLang="ja-JP" dirty="0">
+                  <a:latin typeface="Consolas" panose="020B0609020204030204" pitchFamily="49" charset="0"/>
+                </a:rPr>
+              </a:br>
+              <a:r>
+                <a:rPr lang="en-US" altLang="ja-JP" dirty="0">
+                  <a:latin typeface="Consolas" panose="020B0609020204030204" pitchFamily="49" charset="0"/>
+                </a:rPr>
+                <a:t>actuator hardware</a:t>
+              </a:r>
+              <a:endParaRPr kumimoji="1" lang="ja-JP" altLang="en-US" dirty="0">
+                <a:latin typeface="Consolas" panose="020B0609020204030204" pitchFamily="49" charset="0"/>
+              </a:endParaRPr>
+            </a:p>
+          </p:txBody>
+        </p:sp>
+        <p:cxnSp>
+          <p:nvCxnSpPr>
+            <p:cNvPr id="28" name="直線矢印コネクタ 27">
+              <a:extLst>
+                <a:ext uri="{FF2B5EF4-FFF2-40B4-BE49-F238E27FC236}">
+                  <a16:creationId xmlns:a16="http://schemas.microsoft.com/office/drawing/2014/main" id="{C0EC37AB-4CCF-45CF-B107-75B87BC86580}"/>
+                </a:ext>
+              </a:extLst>
+            </p:cNvPr>
+            <p:cNvCxnSpPr>
+              <a:cxnSpLocks/>
+              <a:stCxn id="24" idx="3"/>
+              <a:endCxn id="27" idx="1"/>
+            </p:cNvCxnSpPr>
+            <p:nvPr/>
+          </p:nvCxnSpPr>
+          <p:spPr>
+            <a:xfrm>
+              <a:off x="5663195" y="5158737"/>
+              <a:ext cx="2364449" cy="0"/>
+            </a:xfrm>
+            <a:prstGeom prst="straightConnector1">
+              <a:avLst/>
+            </a:prstGeom>
+            <a:ln w="19050">
+              <a:solidFill>
+                <a:schemeClr val="tx1"/>
+              </a:solidFill>
+              <a:headEnd type="triangle" w="lg" len="med"/>
+              <a:tailEnd type="triangle" w="lg" len="med"/>
+            </a:ln>
+          </p:spPr>
+          <p:style>
+            <a:lnRef idx="1">
+              <a:schemeClr val="accent1"/>
+            </a:lnRef>
+            <a:fillRef idx="0">
+              <a:schemeClr val="accent1"/>
+            </a:fillRef>
+            <a:effectRef idx="0">
+              <a:schemeClr val="accent1"/>
+            </a:effectRef>
+            <a:fontRef idx="minor">
+              <a:schemeClr val="tx1"/>
+            </a:fontRef>
+          </p:style>
+        </p:cxnSp>
+        <p:cxnSp>
+          <p:nvCxnSpPr>
+            <p:cNvPr id="32" name="直線矢印コネクタ 31">
+              <a:extLst>
+                <a:ext uri="{FF2B5EF4-FFF2-40B4-BE49-F238E27FC236}">
+                  <a16:creationId xmlns:a16="http://schemas.microsoft.com/office/drawing/2014/main" id="{FB68D603-B0BC-4A17-8F2D-AFDC8F3141DA}"/>
+                </a:ext>
+              </a:extLst>
+            </p:cNvPr>
+            <p:cNvCxnSpPr/>
+            <p:nvPr/>
+          </p:nvCxnSpPr>
+          <p:spPr>
+            <a:xfrm>
+              <a:off x="4315438" y="4439246"/>
+              <a:ext cx="0" cy="528623"/>
+            </a:xfrm>
+            <a:prstGeom prst="straightConnector1">
+              <a:avLst/>
+            </a:prstGeom>
+            <a:ln w="19050">
+              <a:solidFill>
+                <a:schemeClr val="tx1"/>
+              </a:solidFill>
+              <a:tailEnd type="triangle" w="lg" len="med"/>
+            </a:ln>
+          </p:spPr>
+          <p:style>
+            <a:lnRef idx="1">
+              <a:schemeClr val="accent1"/>
+            </a:lnRef>
+            <a:fillRef idx="0">
+              <a:schemeClr val="accent1"/>
+            </a:fillRef>
+            <a:effectRef idx="0">
+              <a:schemeClr val="accent1"/>
+            </a:effectRef>
+            <a:fontRef idx="minor">
+              <a:schemeClr val="tx1"/>
+            </a:fontRef>
+          </p:style>
+        </p:cxnSp>
+        <p:cxnSp>
+          <p:nvCxnSpPr>
+            <p:cNvPr id="33" name="直線矢印コネクタ 32">
+              <a:extLst>
+                <a:ext uri="{FF2B5EF4-FFF2-40B4-BE49-F238E27FC236}">
+                  <a16:creationId xmlns:a16="http://schemas.microsoft.com/office/drawing/2014/main" id="{6B36DDD8-5A82-43FC-88AD-2CFDDC8CA8A0}"/>
+                </a:ext>
+              </a:extLst>
+            </p:cNvPr>
+            <p:cNvCxnSpPr>
+              <a:cxnSpLocks/>
+            </p:cNvCxnSpPr>
+            <p:nvPr/>
+          </p:nvCxnSpPr>
+          <p:spPr>
+            <a:xfrm flipV="1">
+              <a:off x="3104653" y="4439246"/>
+              <a:ext cx="0" cy="528623"/>
+            </a:xfrm>
+            <a:prstGeom prst="straightConnector1">
+              <a:avLst/>
+            </a:prstGeom>
+            <a:ln w="19050">
+              <a:solidFill>
+                <a:schemeClr val="tx1"/>
+              </a:solidFill>
+              <a:tailEnd type="triangle" w="lg" len="med"/>
+            </a:ln>
+          </p:spPr>
+          <p:style>
+            <a:lnRef idx="1">
+              <a:schemeClr val="accent1"/>
+            </a:lnRef>
+            <a:fillRef idx="0">
+              <a:schemeClr val="accent1"/>
+            </a:fillRef>
+            <a:effectRef idx="0">
+              <a:schemeClr val="accent1"/>
+            </a:effectRef>
+            <a:fontRef idx="minor">
+              <a:schemeClr val="tx1"/>
+            </a:fontRef>
+          </p:style>
+        </p:cxnSp>
+      </p:grpSp>
+    </p:spTree>
+    <p:extLst>
+      <p:ext uri="{BB962C8B-B14F-4D97-AF65-F5344CB8AC3E}">
+        <p14:creationId xmlns:p14="http://schemas.microsoft.com/office/powerpoint/2010/main" val="3762133557"/>
+      </p:ext>
+    </p:extLst>
+  </p:cSld>
+  <p:clrMapOvr>
+    <a:masterClrMapping/>
+  </p:clrMapOvr>
+</p:sld>
+</file>
+
+<file path=ppt/slides/slide3.xml><?xml version="1.0" encoding="utf-8"?>
+<p:sld xmlns:a="http://schemas.openxmlformats.org/drawingml/2006/main" xmlns:r="http://schemas.openxmlformats.org/officeDocument/2006/relationships" xmlns:p="http://schemas.openxmlformats.org/presentationml/2006/main">
+  <p:cSld>
+    <p:spTree>
+      <p:nvGrpSpPr>
+        <p:cNvPr id="1" name=""/>
+        <p:cNvGrpSpPr/>
+        <p:nvPr/>
+      </p:nvGrpSpPr>
+      <p:grpSpPr>
+        <a:xfrm>
+          <a:off x="0" y="0"/>
+          <a:ext cx="0" cy="0"/>
+          <a:chOff x="0" y="0"/>
+          <a:chExt cx="0" cy="0"/>
+        </a:xfrm>
+      </p:grpSpPr>
+      <p:grpSp>
+        <p:nvGrpSpPr>
+          <p:cNvPr id="2" name="グループ化 1">
+            <a:extLst>
+              <a:ext uri="{FF2B5EF4-FFF2-40B4-BE49-F238E27FC236}">
+                <a16:creationId xmlns:a16="http://schemas.microsoft.com/office/drawing/2014/main" id="{DA953D4E-7FD3-438C-8646-F3097844EADF}"/>
+              </a:ext>
+            </a:extLst>
+          </p:cNvPr>
+          <p:cNvGrpSpPr/>
+          <p:nvPr/>
+        </p:nvGrpSpPr>
+        <p:grpSpPr>
+          <a:xfrm>
+            <a:off x="1223115" y="585788"/>
+            <a:ext cx="4986951" cy="5147444"/>
+            <a:chOff x="1223115" y="585788"/>
+            <a:chExt cx="4986951" cy="5147444"/>
+          </a:xfrm>
+        </p:grpSpPr>
+        <p:sp>
+          <p:nvSpPr>
+            <p:cNvPr id="4" name="正方形/長方形 3">
+              <a:extLst>
+                <a:ext uri="{FF2B5EF4-FFF2-40B4-BE49-F238E27FC236}">
+                  <a16:creationId xmlns:a16="http://schemas.microsoft.com/office/drawing/2014/main" id="{E2783359-64CA-4288-9C73-B05C7D063285}"/>
+                </a:ext>
+              </a:extLst>
+            </p:cNvPr>
+            <p:cNvSpPr/>
+            <p:nvPr/>
+          </p:nvSpPr>
+          <p:spPr>
+            <a:xfrm>
+              <a:off x="1223115" y="585788"/>
+              <a:ext cx="4986951" cy="5147444"/>
+            </a:xfrm>
+            <a:prstGeom prst="rect">
+              <a:avLst/>
+            </a:prstGeom>
+            <a:noFill/>
+            <a:ln w="19050">
+              <a:solidFill>
+                <a:schemeClr val="tx1"/>
+              </a:solidFill>
+            </a:ln>
+          </p:spPr>
+          <p:style>
+            <a:lnRef idx="2">
+              <a:schemeClr val="accent1">
+                <a:shade val="50000"/>
+              </a:schemeClr>
+            </a:lnRef>
+            <a:fillRef idx="1">
+              <a:schemeClr val="accent1"/>
+            </a:fillRef>
+            <a:effectRef idx="0">
+              <a:schemeClr val="accent1"/>
+            </a:effectRef>
+            <a:fontRef idx="minor">
+              <a:schemeClr val="lt1"/>
+            </a:fontRef>
+          </p:style>
+          <p:txBody>
+            <a:bodyPr rtlCol="0" anchor="ctr"/>
+            <a:lstStyle/>
+            <a:p>
+              <a:pPr algn="ctr"/>
+              <a:endParaRPr kumimoji="1" lang="ja-JP" altLang="en-US"/>
+            </a:p>
+          </p:txBody>
+        </p:sp>
+        <p:sp>
+          <p:nvSpPr>
+            <p:cNvPr id="5" name="テキスト ボックス 4">
+              <a:extLst>
+                <a:ext uri="{FF2B5EF4-FFF2-40B4-BE49-F238E27FC236}">
+                  <a16:creationId xmlns:a16="http://schemas.microsoft.com/office/drawing/2014/main" id="{74B68C2D-5E83-4D32-8699-B6AD8A66B7DF}"/>
+                </a:ext>
+              </a:extLst>
+            </p:cNvPr>
+            <p:cNvSpPr txBox="1"/>
+            <p:nvPr/>
+          </p:nvSpPr>
+          <p:spPr>
+            <a:xfrm flipH="1">
+              <a:off x="1307927" y="656347"/>
+              <a:ext cx="4425305" cy="369332"/>
+            </a:xfrm>
+            <a:prstGeom prst="rect">
+              <a:avLst/>
+            </a:prstGeom>
+            <a:noFill/>
+          </p:spPr>
+          <p:txBody>
+            <a:bodyPr wrap="square" rtlCol="0">
+              <a:spAutoFit/>
+            </a:bodyPr>
+            <a:lstStyle/>
+            <a:p>
+              <a:r>
+                <a:rPr lang="en-US" altLang="ja-JP" dirty="0" err="1">
+                  <a:latin typeface="Consolas" panose="020B0609020204030204" pitchFamily="49" charset="0"/>
+                </a:rPr>
+                <a:t>example_l</a:t>
+              </a:r>
+              <a:r>
+                <a:rPr kumimoji="1" lang="en-US" altLang="ja-JP" dirty="0" err="1">
+                  <a:latin typeface="Consolas" panose="020B0609020204030204" pitchFamily="49" charset="0"/>
+                </a:rPr>
+                <a:t>ayered_hardware_node</a:t>
+              </a:r>
+              <a:endParaRPr kumimoji="1" lang="ja-JP" altLang="en-US" dirty="0">
+                <a:latin typeface="Consolas" panose="020B0609020204030204" pitchFamily="49" charset="0"/>
+              </a:endParaRPr>
+            </a:p>
+          </p:txBody>
+        </p:sp>
+        <p:sp>
+          <p:nvSpPr>
+            <p:cNvPr id="6" name="テキスト ボックス 5">
+              <a:extLst>
+                <a:ext uri="{FF2B5EF4-FFF2-40B4-BE49-F238E27FC236}">
+                  <a16:creationId xmlns:a16="http://schemas.microsoft.com/office/drawing/2014/main" id="{03F2FECD-6AB2-477F-8A34-9C91ED6485F3}"/>
+                </a:ext>
+              </a:extLst>
+            </p:cNvPr>
+            <p:cNvSpPr txBox="1"/>
+            <p:nvPr/>
+          </p:nvSpPr>
+          <p:spPr>
+            <a:xfrm>
+              <a:off x="1769984" y="1346350"/>
+              <a:ext cx="3893212" cy="369332"/>
+            </a:xfrm>
+            <a:prstGeom prst="rect">
+              <a:avLst/>
+            </a:prstGeom>
+            <a:noFill/>
+            <a:ln>
+              <a:solidFill>
+                <a:schemeClr val="bg1">
+                  <a:lumMod val="65000"/>
+                </a:schemeClr>
+              </a:solidFill>
+            </a:ln>
+          </p:spPr>
+          <p:txBody>
+            <a:bodyPr wrap="square" rtlCol="0">
+              <a:spAutoFit/>
+            </a:bodyPr>
+            <a:lstStyle/>
+            <a:p>
+              <a:pPr algn="ctr"/>
+              <a:r>
+                <a:rPr kumimoji="1" lang="en-US" altLang="ja-JP" dirty="0" err="1">
+                  <a:latin typeface="Consolas" panose="020B0609020204030204" pitchFamily="49" charset="0"/>
+                </a:rPr>
+                <a:t>ControllerManager</a:t>
+              </a:r>
+              <a:endParaRPr kumimoji="1" lang="ja-JP" altLang="en-US" dirty="0">
+                <a:latin typeface="Consolas" panose="020B0609020204030204" pitchFamily="49" charset="0"/>
+              </a:endParaRPr>
+            </a:p>
+          </p:txBody>
+        </p:sp>
+        <p:sp>
+          <p:nvSpPr>
+            <p:cNvPr id="7" name="テキスト ボックス 6">
+              <a:extLst>
+                <a:ext uri="{FF2B5EF4-FFF2-40B4-BE49-F238E27FC236}">
+                  <a16:creationId xmlns:a16="http://schemas.microsoft.com/office/drawing/2014/main" id="{273FD731-FDFB-4B7C-BE6B-137C53B409A0}"/>
+                </a:ext>
+              </a:extLst>
+            </p:cNvPr>
+            <p:cNvSpPr txBox="1"/>
+            <p:nvPr/>
+          </p:nvSpPr>
+          <p:spPr>
+            <a:xfrm>
+              <a:off x="1769984" y="2244305"/>
+              <a:ext cx="3893212" cy="369332"/>
+            </a:xfrm>
+            <a:prstGeom prst="rect">
+              <a:avLst/>
+            </a:prstGeom>
+            <a:noFill/>
+            <a:ln w="28575">
+              <a:solidFill>
+                <a:schemeClr val="tx1"/>
+              </a:solidFill>
+            </a:ln>
+          </p:spPr>
+          <p:txBody>
+            <a:bodyPr wrap="square" rtlCol="0">
+              <a:spAutoFit/>
+            </a:bodyPr>
+            <a:lstStyle/>
+            <a:p>
+              <a:pPr algn="ctr"/>
+              <a:r>
+                <a:rPr lang="en-US" altLang="ja-JP" dirty="0" err="1">
+                  <a:latin typeface="Consolas" panose="020B0609020204030204" pitchFamily="49" charset="0"/>
+                </a:rPr>
+                <a:t>joint_limits_layer</a:t>
+              </a:r>
+              <a:endParaRPr kumimoji="1" lang="ja-JP" altLang="en-US" sz="1200" dirty="0">
+                <a:latin typeface="Georgia" panose="02040502050405020303" pitchFamily="18" charset="0"/>
+              </a:endParaRPr>
+            </a:p>
+          </p:txBody>
+        </p:sp>
+        <p:sp>
+          <p:nvSpPr>
+            <p:cNvPr id="8" name="テキスト ボックス 7">
+              <a:extLst>
+                <a:ext uri="{FF2B5EF4-FFF2-40B4-BE49-F238E27FC236}">
+                  <a16:creationId xmlns:a16="http://schemas.microsoft.com/office/drawing/2014/main" id="{7BE997F3-C491-47B8-8230-8C3D89A49DC8}"/>
+                </a:ext>
+              </a:extLst>
+            </p:cNvPr>
+            <p:cNvSpPr txBox="1"/>
+            <p:nvPr/>
+          </p:nvSpPr>
+          <p:spPr>
+            <a:xfrm>
+              <a:off x="1769984" y="3153016"/>
+              <a:ext cx="3893212" cy="369332"/>
+            </a:xfrm>
+            <a:prstGeom prst="rect">
+              <a:avLst/>
+            </a:prstGeom>
+            <a:noFill/>
+            <a:ln w="28575">
+              <a:solidFill>
+                <a:schemeClr val="tx1"/>
+              </a:solidFill>
+            </a:ln>
+          </p:spPr>
+          <p:txBody>
+            <a:bodyPr wrap="square" rtlCol="0">
+              <a:spAutoFit/>
+            </a:bodyPr>
+            <a:lstStyle/>
+            <a:p>
+              <a:pPr algn="ctr"/>
+              <a:r>
+                <a:rPr lang="en-US" altLang="ja-JP" dirty="0" err="1">
+                  <a:latin typeface="Consolas" panose="020B0609020204030204" pitchFamily="49" charset="0"/>
+                </a:rPr>
+                <a:t>transmission_layer</a:t>
+              </a:r>
+              <a:endParaRPr lang="en-US" altLang="ja-JP" dirty="0">
+                <a:latin typeface="Consolas" panose="020B0609020204030204" pitchFamily="49" charset="0"/>
+              </a:endParaRPr>
+            </a:p>
+          </p:txBody>
+        </p:sp>
+        <p:sp>
+          <p:nvSpPr>
+            <p:cNvPr id="9" name="テキスト ボックス 8">
+              <a:extLst>
+                <a:ext uri="{FF2B5EF4-FFF2-40B4-BE49-F238E27FC236}">
+                  <a16:creationId xmlns:a16="http://schemas.microsoft.com/office/drawing/2014/main" id="{8AF34787-1E64-424C-AC24-D2FB4ABC6567}"/>
+                </a:ext>
+              </a:extLst>
+            </p:cNvPr>
+            <p:cNvSpPr txBox="1"/>
+            <p:nvPr/>
+          </p:nvSpPr>
+          <p:spPr>
+            <a:xfrm>
+              <a:off x="1769984" y="4069914"/>
+              <a:ext cx="3893212" cy="369332"/>
+            </a:xfrm>
+            <a:prstGeom prst="rect">
+              <a:avLst/>
+            </a:prstGeom>
+            <a:noFill/>
+            <a:ln w="28575">
+              <a:solidFill>
+                <a:schemeClr val="tx1"/>
+              </a:solidFill>
+            </a:ln>
+          </p:spPr>
+          <p:txBody>
+            <a:bodyPr wrap="square" rtlCol="0">
+              <a:spAutoFit/>
+            </a:bodyPr>
+            <a:lstStyle/>
+            <a:p>
+              <a:pPr algn="ctr"/>
+              <a:r>
+                <a:rPr lang="en-US" altLang="ja-JP" dirty="0" err="1">
+                  <a:latin typeface="Consolas" panose="020B0609020204030204" pitchFamily="49" charset="0"/>
+                </a:rPr>
+                <a:t>position_actuator_layer</a:t>
+              </a:r>
+              <a:endParaRPr lang="en-US" altLang="ja-JP" dirty="0">
+                <a:latin typeface="Consolas" panose="020B0609020204030204" pitchFamily="49" charset="0"/>
+              </a:endParaRPr>
+            </a:p>
+          </p:txBody>
+        </p:sp>
+        <p:cxnSp>
+          <p:nvCxnSpPr>
+            <p:cNvPr id="11" name="直線矢印コネクタ 10">
+              <a:extLst>
+                <a:ext uri="{FF2B5EF4-FFF2-40B4-BE49-F238E27FC236}">
+                  <a16:creationId xmlns:a16="http://schemas.microsoft.com/office/drawing/2014/main" id="{30E704C7-38DA-4280-93EA-4AE5D43825EB}"/>
+                </a:ext>
+              </a:extLst>
+            </p:cNvPr>
+            <p:cNvCxnSpPr/>
+            <p:nvPr/>
+          </p:nvCxnSpPr>
+          <p:spPr>
+            <a:xfrm>
+              <a:off x="4315438" y="1715682"/>
+              <a:ext cx="0" cy="528623"/>
+            </a:xfrm>
+            <a:prstGeom prst="straightConnector1">
+              <a:avLst/>
+            </a:prstGeom>
+            <a:ln w="19050">
+              <a:solidFill>
+                <a:schemeClr val="tx1"/>
+              </a:solidFill>
+              <a:tailEnd type="triangle" w="lg" len="med"/>
+            </a:ln>
+          </p:spPr>
+          <p:style>
+            <a:lnRef idx="1">
+              <a:schemeClr val="accent1"/>
+            </a:lnRef>
+            <a:fillRef idx="0">
+              <a:schemeClr val="accent1"/>
+            </a:fillRef>
+            <a:effectRef idx="0">
+              <a:schemeClr val="accent1"/>
+            </a:effectRef>
+            <a:fontRef idx="minor">
+              <a:schemeClr val="tx1"/>
+            </a:fontRef>
+          </p:style>
+        </p:cxnSp>
+        <p:cxnSp>
+          <p:nvCxnSpPr>
+            <p:cNvPr id="12" name="直線矢印コネクタ 11">
+              <a:extLst>
+                <a:ext uri="{FF2B5EF4-FFF2-40B4-BE49-F238E27FC236}">
+                  <a16:creationId xmlns:a16="http://schemas.microsoft.com/office/drawing/2014/main" id="{499CB9A0-4A4D-4698-9A5A-A31B8F2B310C}"/>
+                </a:ext>
+              </a:extLst>
+            </p:cNvPr>
+            <p:cNvCxnSpPr/>
+            <p:nvPr/>
+          </p:nvCxnSpPr>
+          <p:spPr>
+            <a:xfrm>
+              <a:off x="4315438" y="2624393"/>
+              <a:ext cx="0" cy="528623"/>
+            </a:xfrm>
+            <a:prstGeom prst="straightConnector1">
+              <a:avLst/>
+            </a:prstGeom>
+            <a:ln w="19050">
+              <a:solidFill>
+                <a:schemeClr val="tx1"/>
+              </a:solidFill>
+              <a:tailEnd type="triangle" w="lg" len="med"/>
+            </a:ln>
+          </p:spPr>
+          <p:style>
+            <a:lnRef idx="1">
+              <a:schemeClr val="accent1"/>
+            </a:lnRef>
+            <a:fillRef idx="0">
+              <a:schemeClr val="accent1"/>
+            </a:fillRef>
+            <a:effectRef idx="0">
+              <a:schemeClr val="accent1"/>
+            </a:effectRef>
+            <a:fontRef idx="minor">
+              <a:schemeClr val="tx1"/>
+            </a:fontRef>
+          </p:style>
+        </p:cxnSp>
+        <p:cxnSp>
+          <p:nvCxnSpPr>
+            <p:cNvPr id="13" name="直線矢印コネクタ 12">
+              <a:extLst>
+                <a:ext uri="{FF2B5EF4-FFF2-40B4-BE49-F238E27FC236}">
+                  <a16:creationId xmlns:a16="http://schemas.microsoft.com/office/drawing/2014/main" id="{61E7681E-6EE9-4027-BEE9-973B58890744}"/>
+                </a:ext>
+              </a:extLst>
+            </p:cNvPr>
+            <p:cNvCxnSpPr/>
+            <p:nvPr/>
+          </p:nvCxnSpPr>
+          <p:spPr>
+            <a:xfrm>
+              <a:off x="4321983" y="3533108"/>
+              <a:ext cx="0" cy="528623"/>
+            </a:xfrm>
+            <a:prstGeom prst="straightConnector1">
+              <a:avLst/>
+            </a:prstGeom>
+            <a:ln w="19050">
+              <a:solidFill>
+                <a:schemeClr val="tx1"/>
+              </a:solidFill>
+              <a:tailEnd type="triangle" w="lg" len="med"/>
+            </a:ln>
+          </p:spPr>
+          <p:style>
+            <a:lnRef idx="1">
+              <a:schemeClr val="accent1"/>
+            </a:lnRef>
+            <a:fillRef idx="0">
+              <a:schemeClr val="accent1"/>
+            </a:fillRef>
+            <a:effectRef idx="0">
+              <a:schemeClr val="accent1"/>
+            </a:effectRef>
+            <a:fontRef idx="minor">
+              <a:schemeClr val="tx1"/>
+            </a:fontRef>
+          </p:style>
+        </p:cxnSp>
+        <p:cxnSp>
+          <p:nvCxnSpPr>
+            <p:cNvPr id="14" name="直線矢印コネクタ 13">
+              <a:extLst>
+                <a:ext uri="{FF2B5EF4-FFF2-40B4-BE49-F238E27FC236}">
+                  <a16:creationId xmlns:a16="http://schemas.microsoft.com/office/drawing/2014/main" id="{5BDA5ECC-2AA9-4748-8018-AEABFE402207}"/>
+                </a:ext>
+              </a:extLst>
+            </p:cNvPr>
+            <p:cNvCxnSpPr>
+              <a:cxnSpLocks/>
+            </p:cNvCxnSpPr>
+            <p:nvPr/>
+          </p:nvCxnSpPr>
+          <p:spPr>
+            <a:xfrm flipV="1">
+              <a:off x="3111198" y="3533108"/>
+              <a:ext cx="0" cy="528623"/>
+            </a:xfrm>
+            <a:prstGeom prst="straightConnector1">
+              <a:avLst/>
+            </a:prstGeom>
+            <a:ln w="19050">
+              <a:solidFill>
+                <a:schemeClr val="tx1"/>
+              </a:solidFill>
+              <a:tailEnd type="triangle" w="lg" len="med"/>
+            </a:ln>
+          </p:spPr>
+          <p:style>
+            <a:lnRef idx="1">
+              <a:schemeClr val="accent1"/>
+            </a:lnRef>
+            <a:fillRef idx="0">
+              <a:schemeClr val="accent1"/>
+            </a:fillRef>
+            <a:effectRef idx="0">
+              <a:schemeClr val="accent1"/>
+            </a:effectRef>
+            <a:fontRef idx="minor">
+              <a:schemeClr val="tx1"/>
+            </a:fontRef>
+          </p:style>
+        </p:cxnSp>
+        <p:cxnSp>
+          <p:nvCxnSpPr>
+            <p:cNvPr id="15" name="直線矢印コネクタ 14">
+              <a:extLst>
+                <a:ext uri="{FF2B5EF4-FFF2-40B4-BE49-F238E27FC236}">
+                  <a16:creationId xmlns:a16="http://schemas.microsoft.com/office/drawing/2014/main" id="{3133D3B5-441E-420F-8516-5A2E66137F71}"/>
+                </a:ext>
+              </a:extLst>
+            </p:cNvPr>
+            <p:cNvCxnSpPr>
+              <a:cxnSpLocks/>
+            </p:cNvCxnSpPr>
+            <p:nvPr/>
+          </p:nvCxnSpPr>
+          <p:spPr>
+            <a:xfrm flipV="1">
+              <a:off x="3111198" y="2624393"/>
+              <a:ext cx="0" cy="528623"/>
+            </a:xfrm>
+            <a:prstGeom prst="straightConnector1">
+              <a:avLst/>
+            </a:prstGeom>
+            <a:ln w="19050">
+              <a:solidFill>
+                <a:schemeClr val="tx1"/>
+              </a:solidFill>
+              <a:tailEnd type="triangle" w="lg" len="med"/>
+            </a:ln>
+          </p:spPr>
+          <p:style>
+            <a:lnRef idx="1">
+              <a:schemeClr val="accent1"/>
+            </a:lnRef>
+            <a:fillRef idx="0">
+              <a:schemeClr val="accent1"/>
+            </a:fillRef>
+            <a:effectRef idx="0">
+              <a:schemeClr val="accent1"/>
+            </a:effectRef>
+            <a:fontRef idx="minor">
+              <a:schemeClr val="tx1"/>
+            </a:fontRef>
+          </p:style>
+        </p:cxnSp>
+        <p:cxnSp>
+          <p:nvCxnSpPr>
+            <p:cNvPr id="16" name="直線矢印コネクタ 15">
+              <a:extLst>
+                <a:ext uri="{FF2B5EF4-FFF2-40B4-BE49-F238E27FC236}">
+                  <a16:creationId xmlns:a16="http://schemas.microsoft.com/office/drawing/2014/main" id="{01400E0B-4FC1-4839-A89A-B91138FD9A7F}"/>
+                </a:ext>
+              </a:extLst>
+            </p:cNvPr>
+            <p:cNvCxnSpPr>
+              <a:cxnSpLocks/>
+            </p:cNvCxnSpPr>
+            <p:nvPr/>
+          </p:nvCxnSpPr>
+          <p:spPr>
+            <a:xfrm flipV="1">
+              <a:off x="3111198" y="1715682"/>
+              <a:ext cx="0" cy="528623"/>
+            </a:xfrm>
+            <a:prstGeom prst="straightConnector1">
+              <a:avLst/>
+            </a:prstGeom>
+            <a:ln w="19050">
+              <a:solidFill>
+                <a:schemeClr val="tx1"/>
+              </a:solidFill>
+              <a:tailEnd type="triangle" w="lg" len="med"/>
+            </a:ln>
+          </p:spPr>
+          <p:style>
+            <a:lnRef idx="1">
+              <a:schemeClr val="accent1"/>
+            </a:lnRef>
+            <a:fillRef idx="0">
+              <a:schemeClr val="accent1"/>
+            </a:fillRef>
+            <a:effectRef idx="0">
+              <a:schemeClr val="accent1"/>
+            </a:effectRef>
+            <a:fontRef idx="minor">
+              <a:schemeClr val="tx1"/>
+            </a:fontRef>
+          </p:style>
+        </p:cxnSp>
+        <p:sp>
+          <p:nvSpPr>
+            <p:cNvPr id="34" name="テキスト ボックス 33">
+              <a:extLst>
+                <a:ext uri="{FF2B5EF4-FFF2-40B4-BE49-F238E27FC236}">
+                  <a16:creationId xmlns:a16="http://schemas.microsoft.com/office/drawing/2014/main" id="{DF607E99-00F5-4690-96CD-7206F7A8797E}"/>
+                </a:ext>
+              </a:extLst>
+            </p:cNvPr>
+            <p:cNvSpPr txBox="1"/>
+            <p:nvPr/>
+          </p:nvSpPr>
+          <p:spPr>
+            <a:xfrm>
+              <a:off x="4328749" y="1828531"/>
+              <a:ext cx="680816" cy="307777"/>
+            </a:xfrm>
+            <a:prstGeom prst="rect">
+              <a:avLst/>
+            </a:prstGeom>
+            <a:noFill/>
+          </p:spPr>
+          <p:txBody>
+            <a:bodyPr wrap="square" rtlCol="0">
+              <a:spAutoFit/>
+            </a:bodyPr>
+            <a:lstStyle/>
+            <a:p>
+              <a:r>
+                <a:rPr kumimoji="1" lang="en-US" altLang="ja-JP" sz="1400" dirty="0">
+                  <a:latin typeface="Georgia" panose="02040502050405020303" pitchFamily="18" charset="0"/>
+                </a:rPr>
+                <a:t>write</a:t>
+              </a:r>
+              <a:endParaRPr kumimoji="1" lang="ja-JP" altLang="en-US" sz="1400" dirty="0">
+                <a:latin typeface="Georgia" panose="02040502050405020303" pitchFamily="18" charset="0"/>
+              </a:endParaRPr>
+            </a:p>
+          </p:txBody>
+        </p:sp>
+        <p:sp>
+          <p:nvSpPr>
+            <p:cNvPr id="35" name="テキスト ボックス 34">
+              <a:extLst>
+                <a:ext uri="{FF2B5EF4-FFF2-40B4-BE49-F238E27FC236}">
+                  <a16:creationId xmlns:a16="http://schemas.microsoft.com/office/drawing/2014/main" id="{9477A8B0-0A16-4C74-8A84-F14B132B678A}"/>
+                </a:ext>
+              </a:extLst>
+            </p:cNvPr>
+            <p:cNvSpPr txBox="1"/>
+            <p:nvPr/>
+          </p:nvSpPr>
+          <p:spPr>
+            <a:xfrm>
+              <a:off x="3113290" y="1823679"/>
+              <a:ext cx="680816" cy="307777"/>
+            </a:xfrm>
+            <a:prstGeom prst="rect">
+              <a:avLst/>
+            </a:prstGeom>
+            <a:noFill/>
+          </p:spPr>
+          <p:txBody>
+            <a:bodyPr wrap="square" rtlCol="0">
+              <a:spAutoFit/>
+            </a:bodyPr>
+            <a:lstStyle/>
+            <a:p>
+              <a:r>
+                <a:rPr lang="en-US" altLang="ja-JP" sz="1400" dirty="0">
+                  <a:latin typeface="Georgia" panose="02040502050405020303" pitchFamily="18" charset="0"/>
+                </a:rPr>
+                <a:t>r</a:t>
+              </a:r>
+              <a:r>
+                <a:rPr kumimoji="1" lang="en-US" altLang="ja-JP" sz="1400" dirty="0">
+                  <a:latin typeface="Georgia" panose="02040502050405020303" pitchFamily="18" charset="0"/>
+                </a:rPr>
+                <a:t>ead</a:t>
+              </a:r>
+              <a:endParaRPr kumimoji="1" lang="ja-JP" altLang="en-US" sz="1400" dirty="0">
+                <a:latin typeface="Georgia" panose="02040502050405020303" pitchFamily="18" charset="0"/>
+              </a:endParaRPr>
+            </a:p>
+          </p:txBody>
+        </p:sp>
+        <p:sp>
+          <p:nvSpPr>
+            <p:cNvPr id="24" name="テキスト ボックス 23">
+              <a:extLst>
+                <a:ext uri="{FF2B5EF4-FFF2-40B4-BE49-F238E27FC236}">
+                  <a16:creationId xmlns:a16="http://schemas.microsoft.com/office/drawing/2014/main" id="{63C282E4-962F-411F-9A42-11C4F8782399}"/>
+                </a:ext>
+              </a:extLst>
+            </p:cNvPr>
+            <p:cNvSpPr txBox="1"/>
+            <p:nvPr/>
+          </p:nvSpPr>
+          <p:spPr>
+            <a:xfrm>
+              <a:off x="1769983" y="4974071"/>
+              <a:ext cx="3893212" cy="369332"/>
+            </a:xfrm>
+            <a:prstGeom prst="rect">
+              <a:avLst/>
+            </a:prstGeom>
+            <a:noFill/>
+            <a:ln w="28575">
+              <a:solidFill>
+                <a:schemeClr val="tx1"/>
+              </a:solidFill>
+            </a:ln>
+          </p:spPr>
+          <p:txBody>
+            <a:bodyPr wrap="square" rtlCol="0">
+              <a:spAutoFit/>
+            </a:bodyPr>
+            <a:lstStyle/>
+            <a:p>
+              <a:pPr algn="ctr"/>
+              <a:r>
+                <a:rPr lang="en-US" altLang="ja-JP" dirty="0" err="1">
+                  <a:latin typeface="Consolas" panose="020B0609020204030204" pitchFamily="49" charset="0"/>
+                </a:rPr>
+                <a:t>effort_actuator_layer</a:t>
+              </a:r>
+              <a:endParaRPr lang="en-US" altLang="ja-JP" dirty="0">
+                <a:latin typeface="Consolas" panose="020B0609020204030204" pitchFamily="49" charset="0"/>
+              </a:endParaRPr>
+            </a:p>
+          </p:txBody>
+        </p:sp>
+        <p:cxnSp>
+          <p:nvCxnSpPr>
+            <p:cNvPr id="32" name="直線矢印コネクタ 31">
+              <a:extLst>
+                <a:ext uri="{FF2B5EF4-FFF2-40B4-BE49-F238E27FC236}">
+                  <a16:creationId xmlns:a16="http://schemas.microsoft.com/office/drawing/2014/main" id="{FB68D603-B0BC-4A17-8F2D-AFDC8F3141DA}"/>
+                </a:ext>
+              </a:extLst>
+            </p:cNvPr>
+            <p:cNvCxnSpPr/>
+            <p:nvPr/>
+          </p:nvCxnSpPr>
+          <p:spPr>
+            <a:xfrm>
+              <a:off x="4315438" y="4439246"/>
+              <a:ext cx="0" cy="528623"/>
+            </a:xfrm>
+            <a:prstGeom prst="straightConnector1">
+              <a:avLst/>
+            </a:prstGeom>
+            <a:ln w="19050">
+              <a:solidFill>
+                <a:schemeClr val="tx1"/>
+              </a:solidFill>
+              <a:tailEnd type="triangle" w="lg" len="med"/>
+            </a:ln>
+          </p:spPr>
+          <p:style>
+            <a:lnRef idx="1">
+              <a:schemeClr val="accent1"/>
+            </a:lnRef>
+            <a:fillRef idx="0">
+              <a:schemeClr val="accent1"/>
+            </a:fillRef>
+            <a:effectRef idx="0">
+              <a:schemeClr val="accent1"/>
+            </a:effectRef>
+            <a:fontRef idx="minor">
+              <a:schemeClr val="tx1"/>
+            </a:fontRef>
+          </p:style>
+        </p:cxnSp>
+        <p:cxnSp>
+          <p:nvCxnSpPr>
+            <p:cNvPr id="33" name="直線矢印コネクタ 32">
+              <a:extLst>
+                <a:ext uri="{FF2B5EF4-FFF2-40B4-BE49-F238E27FC236}">
+                  <a16:creationId xmlns:a16="http://schemas.microsoft.com/office/drawing/2014/main" id="{6B36DDD8-5A82-43FC-88AD-2CFDDC8CA8A0}"/>
+                </a:ext>
+              </a:extLst>
+            </p:cNvPr>
+            <p:cNvCxnSpPr>
+              <a:cxnSpLocks/>
+            </p:cNvCxnSpPr>
+            <p:nvPr/>
+          </p:nvCxnSpPr>
+          <p:spPr>
+            <a:xfrm flipV="1">
+              <a:off x="3104653" y="4439246"/>
+              <a:ext cx="0" cy="528623"/>
+            </a:xfrm>
+            <a:prstGeom prst="straightConnector1">
+              <a:avLst/>
+            </a:prstGeom>
+            <a:ln w="19050">
+              <a:solidFill>
+                <a:schemeClr val="tx1"/>
+              </a:solidFill>
+              <a:tailEnd type="triangle" w="lg" len="med"/>
+            </a:ln>
+          </p:spPr>
+          <p:style>
+            <a:lnRef idx="1">
+              <a:schemeClr val="accent1"/>
+            </a:lnRef>
+            <a:fillRef idx="0">
+              <a:schemeClr val="accent1"/>
+            </a:fillRef>
+            <a:effectRef idx="0">
+              <a:schemeClr val="accent1"/>
+            </a:effectRef>
+            <a:fontRef idx="minor">
+              <a:schemeClr val="tx1"/>
+            </a:fontRef>
+          </p:style>
+        </p:cxnSp>
+      </p:grpSp>
+    </p:spTree>
+    <p:extLst>
+      <p:ext uri="{BB962C8B-B14F-4D97-AF65-F5344CB8AC3E}">
+        <p14:creationId xmlns:p14="http://schemas.microsoft.com/office/powerpoint/2010/main" val="731646079"/>
+      </p:ext>
+    </p:extLst>
+  </p:cSld>
+  <p:clrMapOvr>
+    <a:masterClrMapping/>
+  </p:clrMapOvr>
+</p:sld>
+</file>
+
+<file path=ppt/slides/slide4.xml><?xml version="1.0" encoding="utf-8"?>
+<p:sld xmlns:a="http://schemas.openxmlformats.org/drawingml/2006/main" xmlns:r="http://schemas.openxmlformats.org/officeDocument/2006/relationships" xmlns:p="http://schemas.openxmlformats.org/presentationml/2006/main">
+  <p:cSld>
+    <p:spTree>
+      <p:nvGrpSpPr>
+        <p:cNvPr id="1" name=""/>
+        <p:cNvGrpSpPr/>
+        <p:nvPr/>
+      </p:nvGrpSpPr>
+      <p:grpSpPr>
+        <a:xfrm>
+          <a:off x="0" y="0"/>
+          <a:ext cx="0" cy="0"/>
+          <a:chOff x="0" y="0"/>
+          <a:chExt cx="0" cy="0"/>
+        </a:xfrm>
+      </p:grpSpPr>
+      <p:grpSp>
+        <p:nvGrpSpPr>
+          <p:cNvPr id="32" name="グループ化 31">
+            <a:extLst>
+              <a:ext uri="{FF2B5EF4-FFF2-40B4-BE49-F238E27FC236}">
+                <a16:creationId xmlns:a16="http://schemas.microsoft.com/office/drawing/2014/main" id="{86090B9E-1A59-EB9B-9054-9EC655FC3A63}"/>
+              </a:ext>
+            </a:extLst>
+          </p:cNvPr>
+          <p:cNvGrpSpPr/>
+          <p:nvPr/>
+        </p:nvGrpSpPr>
+        <p:grpSpPr>
+          <a:xfrm>
+            <a:off x="1223115" y="660485"/>
+            <a:ext cx="9994648" cy="5419184"/>
+            <a:chOff x="1223115" y="660485"/>
+            <a:chExt cx="9994648" cy="5419184"/>
+          </a:xfrm>
+        </p:grpSpPr>
+        <p:sp>
+          <p:nvSpPr>
+            <p:cNvPr id="4" name="正方形/長方形 3">
+              <a:extLst>
+                <a:ext uri="{FF2B5EF4-FFF2-40B4-BE49-F238E27FC236}">
+                  <a16:creationId xmlns:a16="http://schemas.microsoft.com/office/drawing/2014/main" id="{CE54F339-B96F-0C6B-C313-4909F59FDF45}"/>
+                </a:ext>
+              </a:extLst>
+            </p:cNvPr>
+            <p:cNvSpPr/>
+            <p:nvPr/>
+          </p:nvSpPr>
+          <p:spPr>
+            <a:xfrm>
+              <a:off x="1223115" y="660485"/>
+              <a:ext cx="4986951" cy="5314601"/>
+            </a:xfrm>
+            <a:prstGeom prst="rect">
+              <a:avLst/>
+            </a:prstGeom>
+            <a:noFill/>
+            <a:ln w="19050">
+              <a:solidFill>
+                <a:schemeClr val="tx1"/>
+              </a:solidFill>
+            </a:ln>
+          </p:spPr>
+          <p:style>
+            <a:lnRef idx="2">
+              <a:schemeClr val="accent1">
+                <a:shade val="50000"/>
+              </a:schemeClr>
+            </a:lnRef>
+            <a:fillRef idx="1">
+              <a:schemeClr val="accent1"/>
+            </a:fillRef>
+            <a:effectRef idx="0">
+              <a:schemeClr val="accent1"/>
+            </a:effectRef>
+            <a:fontRef idx="minor">
+              <a:schemeClr val="lt1"/>
+            </a:fontRef>
+          </p:style>
+          <p:txBody>
+            <a:bodyPr rtlCol="0" anchor="ctr"/>
+            <a:lstStyle/>
+            <a:p>
+              <a:pPr algn="ctr"/>
+              <a:endParaRPr kumimoji="1" lang="ja-JP" altLang="en-US"/>
+            </a:p>
+          </p:txBody>
+        </p:sp>
+        <p:sp>
+          <p:nvSpPr>
+            <p:cNvPr id="5" name="テキスト ボックス 4">
+              <a:extLst>
+                <a:ext uri="{FF2B5EF4-FFF2-40B4-BE49-F238E27FC236}">
+                  <a16:creationId xmlns:a16="http://schemas.microsoft.com/office/drawing/2014/main" id="{24D68003-CC30-2A66-647E-C3A1889F747A}"/>
+                </a:ext>
+              </a:extLst>
+            </p:cNvPr>
+            <p:cNvSpPr txBox="1"/>
+            <p:nvPr/>
+          </p:nvSpPr>
+          <p:spPr>
+            <a:xfrm flipH="1">
+              <a:off x="1307927" y="660485"/>
+              <a:ext cx="4425305" cy="369332"/>
+            </a:xfrm>
+            <a:prstGeom prst="rect">
+              <a:avLst/>
+            </a:prstGeom>
+            <a:noFill/>
+          </p:spPr>
+          <p:txBody>
+            <a:bodyPr wrap="square" rtlCol="0">
+              <a:spAutoFit/>
+            </a:bodyPr>
+            <a:lstStyle/>
+            <a:p>
+              <a:r>
+                <a:rPr kumimoji="1" lang="en-US" altLang="ja-JP" dirty="0">
+                  <a:latin typeface="Consolas" panose="020B0609020204030204" pitchFamily="49" charset="0"/>
+                </a:rPr>
+                <a:t>ros2_control_node</a:t>
+              </a:r>
+              <a:endParaRPr kumimoji="1" lang="ja-JP" altLang="en-US" dirty="0">
+                <a:latin typeface="Consolas" panose="020B0609020204030204" pitchFamily="49" charset="0"/>
+              </a:endParaRPr>
+            </a:p>
+          </p:txBody>
+        </p:sp>
+        <p:sp>
+          <p:nvSpPr>
+            <p:cNvPr id="6" name="テキスト ボックス 5">
+              <a:extLst>
+                <a:ext uri="{FF2B5EF4-FFF2-40B4-BE49-F238E27FC236}">
+                  <a16:creationId xmlns:a16="http://schemas.microsoft.com/office/drawing/2014/main" id="{18E88D91-4BA1-B578-8A0B-5E842F795859}"/>
+                </a:ext>
+              </a:extLst>
+            </p:cNvPr>
+            <p:cNvSpPr txBox="1"/>
+            <p:nvPr/>
+          </p:nvSpPr>
+          <p:spPr>
+            <a:xfrm>
+              <a:off x="1769984" y="2190020"/>
+              <a:ext cx="3893212" cy="369332"/>
+            </a:xfrm>
+            <a:prstGeom prst="rect">
+              <a:avLst/>
+            </a:prstGeom>
+            <a:noFill/>
+            <a:ln>
+              <a:solidFill>
+                <a:schemeClr val="bg1">
+                  <a:lumMod val="65000"/>
+                </a:schemeClr>
+              </a:solidFill>
+            </a:ln>
+          </p:spPr>
+          <p:txBody>
+            <a:bodyPr wrap="square" rtlCol="0">
+              <a:spAutoFit/>
+            </a:bodyPr>
+            <a:lstStyle/>
+            <a:p>
+              <a:pPr algn="ctr"/>
+              <a:r>
+                <a:rPr kumimoji="1" lang="en-US" altLang="ja-JP" dirty="0" err="1">
+                  <a:latin typeface="Consolas" panose="020B0609020204030204" pitchFamily="49" charset="0"/>
+                </a:rPr>
+                <a:t>ResourceManager</a:t>
+              </a:r>
+              <a:endParaRPr kumimoji="1" lang="ja-JP" altLang="en-US" dirty="0">
+                <a:latin typeface="Consolas" panose="020B0609020204030204" pitchFamily="49" charset="0"/>
+              </a:endParaRPr>
+            </a:p>
+          </p:txBody>
+        </p:sp>
+        <p:sp>
+          <p:nvSpPr>
+            <p:cNvPr id="7" name="テキスト ボックス 6">
+              <a:extLst>
+                <a:ext uri="{FF2B5EF4-FFF2-40B4-BE49-F238E27FC236}">
+                  <a16:creationId xmlns:a16="http://schemas.microsoft.com/office/drawing/2014/main" id="{8AB88724-10B2-134F-7304-D58899F7B883}"/>
+                </a:ext>
+              </a:extLst>
+            </p:cNvPr>
+            <p:cNvSpPr txBox="1"/>
+            <p:nvPr/>
+          </p:nvSpPr>
+          <p:spPr>
+            <a:xfrm>
+              <a:off x="1769984" y="3396789"/>
+              <a:ext cx="3893212" cy="369332"/>
+            </a:xfrm>
+            <a:prstGeom prst="rect">
+              <a:avLst/>
+            </a:prstGeom>
+            <a:noFill/>
+            <a:ln w="28575">
+              <a:solidFill>
+                <a:schemeClr val="tx1"/>
+              </a:solidFill>
+            </a:ln>
+          </p:spPr>
+          <p:txBody>
+            <a:bodyPr wrap="square" rtlCol="0">
+              <a:spAutoFit/>
+            </a:bodyPr>
+            <a:lstStyle/>
+            <a:p>
+              <a:pPr algn="ctr"/>
+              <a:r>
+                <a:rPr lang="en-US" altLang="ja-JP" dirty="0">
+                  <a:latin typeface="Consolas" panose="020B0609020204030204" pitchFamily="49" charset="0"/>
+                </a:rPr>
+                <a:t>Layer[0]</a:t>
+              </a:r>
+              <a:r>
+                <a:rPr lang="ja-JP" altLang="en-US" sz="1200" dirty="0">
+                  <a:latin typeface="Georgia" panose="02040502050405020303" pitchFamily="18" charset="0"/>
+                </a:rPr>
+                <a:t> </a:t>
+              </a:r>
+              <a:r>
+                <a:rPr kumimoji="1" lang="en-US" altLang="ja-JP" sz="1200" dirty="0">
+                  <a:latin typeface="Georgia" panose="02040502050405020303" pitchFamily="18" charset="0"/>
+                </a:rPr>
+                <a:t>(ex. Joint limits)</a:t>
+              </a:r>
+              <a:endParaRPr kumimoji="1" lang="ja-JP" altLang="en-US" sz="1200" dirty="0">
+                <a:latin typeface="Georgia" panose="02040502050405020303" pitchFamily="18" charset="0"/>
+              </a:endParaRPr>
+            </a:p>
+          </p:txBody>
+        </p:sp>
+        <p:sp>
+          <p:nvSpPr>
+            <p:cNvPr id="8" name="テキスト ボックス 7">
+              <a:extLst>
+                <a:ext uri="{FF2B5EF4-FFF2-40B4-BE49-F238E27FC236}">
+                  <a16:creationId xmlns:a16="http://schemas.microsoft.com/office/drawing/2014/main" id="{85D89F10-EA7B-62C3-09D6-BB1BA3B0D3CE}"/>
+                </a:ext>
+              </a:extLst>
+            </p:cNvPr>
+            <p:cNvSpPr txBox="1"/>
+            <p:nvPr/>
+          </p:nvSpPr>
+          <p:spPr>
+            <a:xfrm>
+              <a:off x="1769984" y="4299034"/>
+              <a:ext cx="3893212" cy="369332"/>
+            </a:xfrm>
+            <a:prstGeom prst="rect">
+              <a:avLst/>
+            </a:prstGeom>
+            <a:noFill/>
+            <a:ln w="28575">
+              <a:solidFill>
+                <a:schemeClr val="tx1"/>
+              </a:solidFill>
+            </a:ln>
+          </p:spPr>
+          <p:txBody>
+            <a:bodyPr wrap="square" rtlCol="0">
+              <a:spAutoFit/>
+            </a:bodyPr>
+            <a:lstStyle/>
+            <a:p>
+              <a:pPr algn="ctr"/>
+              <a:r>
+                <a:rPr lang="en-US" altLang="ja-JP" dirty="0">
+                  <a:latin typeface="Consolas" panose="020B0609020204030204" pitchFamily="49" charset="0"/>
+                </a:rPr>
+                <a:t>Layer[1]</a:t>
+              </a:r>
+              <a:r>
+                <a:rPr lang="ja-JP" altLang="en-US" sz="1200" dirty="0">
+                  <a:solidFill>
+                    <a:prstClr val="black"/>
+                  </a:solidFill>
+                  <a:latin typeface="Georgia" panose="02040502050405020303" pitchFamily="18" charset="0"/>
+                </a:rPr>
+                <a:t> </a:t>
+              </a:r>
+              <a:r>
+                <a:rPr lang="en-US" altLang="ja-JP" sz="1200" dirty="0">
+                  <a:solidFill>
+                    <a:prstClr val="black"/>
+                  </a:solidFill>
+                  <a:latin typeface="Georgia" panose="02040502050405020303" pitchFamily="18" charset="0"/>
+                </a:rPr>
+                <a:t>(ex. Transmissions)</a:t>
+              </a:r>
+              <a:endParaRPr kumimoji="1" lang="ja-JP" altLang="en-US" dirty="0">
+                <a:latin typeface="Consolas" panose="020B0609020204030204" pitchFamily="49" charset="0"/>
+              </a:endParaRPr>
+            </a:p>
+          </p:txBody>
+        </p:sp>
+        <p:sp>
+          <p:nvSpPr>
+            <p:cNvPr id="9" name="テキスト ボックス 8">
+              <a:extLst>
+                <a:ext uri="{FF2B5EF4-FFF2-40B4-BE49-F238E27FC236}">
+                  <a16:creationId xmlns:a16="http://schemas.microsoft.com/office/drawing/2014/main" id="{1BF04B77-2D1D-796E-F768-DB4541CD2BD3}"/>
+                </a:ext>
+              </a:extLst>
+            </p:cNvPr>
+            <p:cNvSpPr txBox="1"/>
+            <p:nvPr/>
+          </p:nvSpPr>
+          <p:spPr>
+            <a:xfrm>
+              <a:off x="1769984" y="5203780"/>
+              <a:ext cx="3893212" cy="369332"/>
+            </a:xfrm>
+            <a:prstGeom prst="rect">
+              <a:avLst/>
+            </a:prstGeom>
+            <a:noFill/>
+            <a:ln w="28575">
+              <a:solidFill>
+                <a:schemeClr val="tx1"/>
+              </a:solidFill>
+            </a:ln>
+          </p:spPr>
+          <p:txBody>
+            <a:bodyPr wrap="square" rtlCol="0">
+              <a:spAutoFit/>
+            </a:bodyPr>
+            <a:lstStyle/>
+            <a:p>
+              <a:pPr algn="ctr"/>
+              <a:r>
+                <a:rPr lang="en-US" altLang="ja-JP" dirty="0">
+                  <a:latin typeface="Consolas" panose="020B0609020204030204" pitchFamily="49" charset="0"/>
+                </a:rPr>
+                <a:t>Layer[2]</a:t>
+              </a:r>
+              <a:r>
+                <a:rPr lang="en-US" altLang="ja-JP" sz="1200" dirty="0">
+                  <a:solidFill>
+                    <a:prstClr val="black"/>
+                  </a:solidFill>
+                  <a:latin typeface="Georgia" panose="02040502050405020303" pitchFamily="18" charset="0"/>
+                </a:rPr>
+                <a:t> (ex. Actuator-specific)</a:t>
+              </a:r>
+              <a:endParaRPr kumimoji="1" lang="ja-JP" altLang="en-US" dirty="0">
+                <a:latin typeface="Consolas" panose="020B0609020204030204" pitchFamily="49" charset="0"/>
+              </a:endParaRPr>
+            </a:p>
+          </p:txBody>
+        </p:sp>
+        <p:cxnSp>
+          <p:nvCxnSpPr>
+            <p:cNvPr id="10" name="直線矢印コネクタ 9">
+              <a:extLst>
+                <a:ext uri="{FF2B5EF4-FFF2-40B4-BE49-F238E27FC236}">
+                  <a16:creationId xmlns:a16="http://schemas.microsoft.com/office/drawing/2014/main" id="{7B901AEA-3C50-3E7D-15F2-266977665F65}"/>
+                </a:ext>
+              </a:extLst>
+            </p:cNvPr>
+            <p:cNvCxnSpPr/>
+            <p:nvPr/>
+          </p:nvCxnSpPr>
+          <p:spPr>
+            <a:xfrm>
+              <a:off x="4315438" y="3770411"/>
+              <a:ext cx="0" cy="528623"/>
+            </a:xfrm>
+            <a:prstGeom prst="straightConnector1">
+              <a:avLst/>
+            </a:prstGeom>
+            <a:ln w="19050">
+              <a:solidFill>
+                <a:schemeClr val="tx1"/>
+              </a:solidFill>
+              <a:tailEnd type="triangle" w="lg" len="med"/>
+            </a:ln>
+          </p:spPr>
+          <p:style>
+            <a:lnRef idx="1">
+              <a:schemeClr val="accent1"/>
+            </a:lnRef>
+            <a:fillRef idx="0">
+              <a:schemeClr val="accent1"/>
+            </a:fillRef>
+            <a:effectRef idx="0">
+              <a:schemeClr val="accent1"/>
+            </a:effectRef>
+            <a:fontRef idx="minor">
+              <a:schemeClr val="tx1"/>
+            </a:fontRef>
+          </p:style>
+        </p:cxnSp>
+        <p:cxnSp>
+          <p:nvCxnSpPr>
+            <p:cNvPr id="11" name="直線矢印コネクタ 10">
+              <a:extLst>
+                <a:ext uri="{FF2B5EF4-FFF2-40B4-BE49-F238E27FC236}">
+                  <a16:creationId xmlns:a16="http://schemas.microsoft.com/office/drawing/2014/main" id="{47563BE4-E0DF-626B-D353-8F8A674ED18D}"/>
+                </a:ext>
+              </a:extLst>
+            </p:cNvPr>
+            <p:cNvCxnSpPr/>
+            <p:nvPr/>
+          </p:nvCxnSpPr>
+          <p:spPr>
+            <a:xfrm>
+              <a:off x="4321983" y="4675157"/>
+              <a:ext cx="0" cy="528623"/>
+            </a:xfrm>
+            <a:prstGeom prst="straightConnector1">
+              <a:avLst/>
+            </a:prstGeom>
+            <a:ln w="19050">
+              <a:solidFill>
+                <a:schemeClr val="tx1"/>
+              </a:solidFill>
+              <a:tailEnd type="triangle" w="lg" len="med"/>
+            </a:ln>
+          </p:spPr>
+          <p:style>
+            <a:lnRef idx="1">
+              <a:schemeClr val="accent1"/>
+            </a:lnRef>
+            <a:fillRef idx="0">
+              <a:schemeClr val="accent1"/>
+            </a:fillRef>
+            <a:effectRef idx="0">
+              <a:schemeClr val="accent1"/>
+            </a:effectRef>
+            <a:fontRef idx="minor">
+              <a:schemeClr val="tx1"/>
+            </a:fontRef>
+          </p:style>
+        </p:cxnSp>
+        <p:cxnSp>
+          <p:nvCxnSpPr>
+            <p:cNvPr id="12" name="直線矢印コネクタ 11">
+              <a:extLst>
+                <a:ext uri="{FF2B5EF4-FFF2-40B4-BE49-F238E27FC236}">
+                  <a16:creationId xmlns:a16="http://schemas.microsoft.com/office/drawing/2014/main" id="{5EBC3427-CF0A-11D7-BB68-3A0B397A21A9}"/>
+                </a:ext>
+              </a:extLst>
+            </p:cNvPr>
+            <p:cNvCxnSpPr>
+              <a:cxnSpLocks/>
+            </p:cNvCxnSpPr>
+            <p:nvPr/>
+          </p:nvCxnSpPr>
+          <p:spPr>
+            <a:xfrm flipV="1">
+              <a:off x="3111198" y="4675157"/>
+              <a:ext cx="0" cy="528623"/>
+            </a:xfrm>
+            <a:prstGeom prst="straightConnector1">
+              <a:avLst/>
+            </a:prstGeom>
+            <a:ln w="19050">
+              <a:solidFill>
+                <a:schemeClr val="tx1"/>
+              </a:solidFill>
+              <a:tailEnd type="triangle" w="lg" len="med"/>
+            </a:ln>
+          </p:spPr>
+          <p:style>
+            <a:lnRef idx="1">
+              <a:schemeClr val="accent1"/>
+            </a:lnRef>
+            <a:fillRef idx="0">
+              <a:schemeClr val="accent1"/>
+            </a:fillRef>
+            <a:effectRef idx="0">
+              <a:schemeClr val="accent1"/>
+            </a:effectRef>
+            <a:fontRef idx="minor">
+              <a:schemeClr val="tx1"/>
+            </a:fontRef>
+          </p:style>
+        </p:cxnSp>
+        <p:cxnSp>
+          <p:nvCxnSpPr>
+            <p:cNvPr id="13" name="直線矢印コネクタ 12">
+              <a:extLst>
+                <a:ext uri="{FF2B5EF4-FFF2-40B4-BE49-F238E27FC236}">
+                  <a16:creationId xmlns:a16="http://schemas.microsoft.com/office/drawing/2014/main" id="{2FEB19BA-D626-D628-835F-FC91610256F8}"/>
+                </a:ext>
+              </a:extLst>
+            </p:cNvPr>
+            <p:cNvCxnSpPr>
+              <a:cxnSpLocks/>
+            </p:cNvCxnSpPr>
+            <p:nvPr/>
+          </p:nvCxnSpPr>
+          <p:spPr>
+            <a:xfrm flipV="1">
+              <a:off x="3111198" y="3770411"/>
+              <a:ext cx="0" cy="528623"/>
+            </a:xfrm>
+            <a:prstGeom prst="straightConnector1">
+              <a:avLst/>
+            </a:prstGeom>
+            <a:ln w="19050">
+              <a:solidFill>
+                <a:schemeClr val="tx1"/>
+              </a:solidFill>
+              <a:tailEnd type="triangle" w="lg" len="med"/>
+            </a:ln>
+          </p:spPr>
+          <p:style>
+            <a:lnRef idx="1">
+              <a:schemeClr val="accent1"/>
+            </a:lnRef>
+            <a:fillRef idx="0">
+              <a:schemeClr val="accent1"/>
+            </a:fillRef>
+            <a:effectRef idx="0">
+              <a:schemeClr val="accent1"/>
+            </a:effectRef>
+            <a:fontRef idx="minor">
+              <a:schemeClr val="tx1"/>
+            </a:fontRef>
+          </p:style>
+        </p:cxnSp>
+        <p:sp>
+          <p:nvSpPr>
+            <p:cNvPr id="14" name="テキスト ボックス 13">
+              <a:extLst>
+                <a:ext uri="{FF2B5EF4-FFF2-40B4-BE49-F238E27FC236}">
+                  <a16:creationId xmlns:a16="http://schemas.microsoft.com/office/drawing/2014/main" id="{307E640B-C1EE-3F4E-F008-5069BCDC6ED2}"/>
+                </a:ext>
+              </a:extLst>
+            </p:cNvPr>
+            <p:cNvSpPr txBox="1"/>
+            <p:nvPr/>
+          </p:nvSpPr>
+          <p:spPr>
+            <a:xfrm>
+              <a:off x="8038780" y="1123547"/>
+              <a:ext cx="3178983" cy="369332"/>
+            </a:xfrm>
+            <a:prstGeom prst="rect">
+              <a:avLst/>
+            </a:prstGeom>
+            <a:noFill/>
+            <a:ln>
+              <a:solidFill>
+                <a:schemeClr val="bg1">
+                  <a:lumMod val="65000"/>
+                </a:schemeClr>
+              </a:solidFill>
+            </a:ln>
+          </p:spPr>
+          <p:txBody>
+            <a:bodyPr wrap="square" rtlCol="0">
+              <a:spAutoFit/>
+            </a:bodyPr>
+            <a:lstStyle/>
+            <a:p>
+              <a:pPr algn="ctr"/>
+              <a:r>
+                <a:rPr kumimoji="1" lang="en-US" altLang="ja-JP" dirty="0">
+                  <a:latin typeface="Consolas" panose="020B0609020204030204" pitchFamily="49" charset="0"/>
+                </a:rPr>
+                <a:t>User ROS nodes</a:t>
+              </a:r>
+              <a:endParaRPr kumimoji="1" lang="ja-JP" altLang="en-US" dirty="0">
+                <a:latin typeface="Consolas" panose="020B0609020204030204" pitchFamily="49" charset="0"/>
+              </a:endParaRPr>
+            </a:p>
+          </p:txBody>
+        </p:sp>
+        <p:sp>
+          <p:nvSpPr>
+            <p:cNvPr id="15" name="テキスト ボックス 14">
+              <a:extLst>
+                <a:ext uri="{FF2B5EF4-FFF2-40B4-BE49-F238E27FC236}">
+                  <a16:creationId xmlns:a16="http://schemas.microsoft.com/office/drawing/2014/main" id="{7394905E-2377-4FEC-C3B4-67355A4E447D}"/>
+                </a:ext>
+              </a:extLst>
+            </p:cNvPr>
+            <p:cNvSpPr txBox="1"/>
+            <p:nvPr/>
+          </p:nvSpPr>
+          <p:spPr>
+            <a:xfrm>
+              <a:off x="8027645" y="5105519"/>
+              <a:ext cx="3178984" cy="553998"/>
+            </a:xfrm>
+            <a:prstGeom prst="rect">
+              <a:avLst/>
+            </a:prstGeom>
+            <a:noFill/>
+            <a:ln>
+              <a:solidFill>
+                <a:schemeClr val="bg1">
+                  <a:lumMod val="65000"/>
+                </a:schemeClr>
+              </a:solidFill>
+            </a:ln>
+          </p:spPr>
+          <p:txBody>
+            <a:bodyPr wrap="square" rtlCol="0" anchor="ctr" anchorCtr="0">
+              <a:noAutofit/>
+            </a:bodyPr>
+            <a:lstStyle/>
+            <a:p>
+              <a:pPr algn="ctr"/>
+              <a:r>
+                <a:rPr lang="en-US" altLang="ja-JP" dirty="0">
+                  <a:latin typeface="Consolas" panose="020B0609020204030204" pitchFamily="49" charset="0"/>
+                </a:rPr>
+                <a:t>Actuator hardware</a:t>
+              </a:r>
+              <a:endParaRPr kumimoji="1" lang="ja-JP" altLang="en-US" dirty="0">
+                <a:latin typeface="Consolas" panose="020B0609020204030204" pitchFamily="49" charset="0"/>
+              </a:endParaRPr>
+            </a:p>
+          </p:txBody>
+        </p:sp>
+        <p:cxnSp>
+          <p:nvCxnSpPr>
+            <p:cNvPr id="16" name="直線矢印コネクタ 15">
+              <a:extLst>
+                <a:ext uri="{FF2B5EF4-FFF2-40B4-BE49-F238E27FC236}">
+                  <a16:creationId xmlns:a16="http://schemas.microsoft.com/office/drawing/2014/main" id="{FC4CF29D-87AC-2083-6E36-45D9CACA64E2}"/>
+                </a:ext>
+              </a:extLst>
+            </p:cNvPr>
+            <p:cNvCxnSpPr>
+              <a:cxnSpLocks/>
+              <a:stCxn id="23" idx="3"/>
+              <a:endCxn id="14" idx="1"/>
+            </p:cNvCxnSpPr>
+            <p:nvPr/>
+          </p:nvCxnSpPr>
+          <p:spPr>
+            <a:xfrm>
+              <a:off x="5663196" y="1303963"/>
+              <a:ext cx="2375584" cy="4250"/>
+            </a:xfrm>
+            <a:prstGeom prst="straightConnector1">
+              <a:avLst/>
+            </a:prstGeom>
+            <a:ln w="19050">
+              <a:solidFill>
+                <a:schemeClr val="tx1"/>
+              </a:solidFill>
+              <a:headEnd type="triangle" w="lg" len="med"/>
+              <a:tailEnd type="triangle" w="lg" len="med"/>
+            </a:ln>
+          </p:spPr>
+          <p:style>
+            <a:lnRef idx="1">
+              <a:schemeClr val="accent1"/>
+            </a:lnRef>
+            <a:fillRef idx="0">
+              <a:schemeClr val="accent1"/>
+            </a:fillRef>
+            <a:effectRef idx="0">
+              <a:schemeClr val="accent1"/>
+            </a:effectRef>
+            <a:fontRef idx="minor">
+              <a:schemeClr val="tx1"/>
+            </a:fontRef>
+          </p:style>
+        </p:cxnSp>
+        <p:cxnSp>
+          <p:nvCxnSpPr>
+            <p:cNvPr id="17" name="直線矢印コネクタ 16">
+              <a:extLst>
+                <a:ext uri="{FF2B5EF4-FFF2-40B4-BE49-F238E27FC236}">
+                  <a16:creationId xmlns:a16="http://schemas.microsoft.com/office/drawing/2014/main" id="{063DD8F6-E465-B47E-9513-9377B770E57E}"/>
+                </a:ext>
+              </a:extLst>
+            </p:cNvPr>
+            <p:cNvCxnSpPr>
+              <a:cxnSpLocks/>
+              <a:endCxn id="15" idx="1"/>
+            </p:cNvCxnSpPr>
+            <p:nvPr/>
+          </p:nvCxnSpPr>
+          <p:spPr>
+            <a:xfrm>
+              <a:off x="6014360" y="5382518"/>
+              <a:ext cx="2013285" cy="0"/>
+            </a:xfrm>
+            <a:prstGeom prst="straightConnector1">
+              <a:avLst/>
+            </a:prstGeom>
+            <a:ln w="19050">
+              <a:solidFill>
+                <a:schemeClr val="tx1"/>
+              </a:solidFill>
+              <a:headEnd type="triangle" w="lg" len="med"/>
+              <a:tailEnd type="triangle" w="lg" len="med"/>
+            </a:ln>
+          </p:spPr>
+          <p:style>
+            <a:lnRef idx="1">
+              <a:schemeClr val="accent1"/>
+            </a:lnRef>
+            <a:fillRef idx="0">
+              <a:schemeClr val="accent1"/>
+            </a:fillRef>
+            <a:effectRef idx="0">
+              <a:schemeClr val="accent1"/>
+            </a:effectRef>
+            <a:fontRef idx="minor">
+              <a:schemeClr val="tx1"/>
+            </a:fontRef>
+          </p:style>
+        </p:cxnSp>
+        <p:sp>
+          <p:nvSpPr>
+            <p:cNvPr id="18" name="テキスト ボックス 17">
+              <a:extLst>
+                <a:ext uri="{FF2B5EF4-FFF2-40B4-BE49-F238E27FC236}">
+                  <a16:creationId xmlns:a16="http://schemas.microsoft.com/office/drawing/2014/main" id="{BE29E8DA-F16F-FB9F-4CAB-4B4975E01986}"/>
+                </a:ext>
+              </a:extLst>
+            </p:cNvPr>
+            <p:cNvSpPr txBox="1"/>
+            <p:nvPr/>
+          </p:nvSpPr>
+          <p:spPr>
+            <a:xfrm>
+              <a:off x="6259536" y="5341005"/>
+              <a:ext cx="3076823" cy="738664"/>
+            </a:xfrm>
+            <a:prstGeom prst="rect">
+              <a:avLst/>
+            </a:prstGeom>
+            <a:noFill/>
+          </p:spPr>
+          <p:txBody>
+            <a:bodyPr wrap="square" rtlCol="0">
+              <a:spAutoFit/>
+            </a:bodyPr>
+            <a:lstStyle/>
+            <a:p>
+              <a:r>
+                <a:rPr kumimoji="1" lang="en-US" altLang="ja-JP" sz="1400" dirty="0">
+                  <a:latin typeface="Georgia" panose="02040502050405020303" pitchFamily="18" charset="0"/>
+                </a:rPr>
+                <a:t>read states /</a:t>
+              </a:r>
+              <a:br>
+                <a:rPr kumimoji="1" lang="en-US" altLang="ja-JP" sz="1400" dirty="0">
+                  <a:latin typeface="Georgia" panose="02040502050405020303" pitchFamily="18" charset="0"/>
+                </a:rPr>
+              </a:br>
+              <a:r>
+                <a:rPr kumimoji="1" lang="en-US" altLang="ja-JP" sz="1400" dirty="0">
+                  <a:latin typeface="Georgia" panose="02040502050405020303" pitchFamily="18" charset="0"/>
+                </a:rPr>
+                <a:t>write commands</a:t>
+              </a:r>
+              <a:br>
+                <a:rPr kumimoji="1" lang="en-US" altLang="ja-JP" sz="1400" dirty="0">
+                  <a:latin typeface="Georgia" panose="02040502050405020303" pitchFamily="18" charset="0"/>
+                </a:rPr>
+              </a:br>
+              <a:r>
+                <a:rPr kumimoji="1" lang="en-US" altLang="ja-JP" sz="1400" dirty="0">
+                  <a:latin typeface="Georgia" panose="02040502050405020303" pitchFamily="18" charset="0"/>
+                </a:rPr>
+                <a:t>via actuator-specific interface</a:t>
+              </a:r>
+              <a:endParaRPr kumimoji="1" lang="ja-JP" altLang="en-US" sz="1400" dirty="0">
+                <a:latin typeface="Georgia" panose="02040502050405020303" pitchFamily="18" charset="0"/>
+              </a:endParaRPr>
+            </a:p>
+          </p:txBody>
+        </p:sp>
+        <p:sp>
+          <p:nvSpPr>
+            <p:cNvPr id="19" name="テキスト ボックス 18">
+              <a:extLst>
+                <a:ext uri="{FF2B5EF4-FFF2-40B4-BE49-F238E27FC236}">
+                  <a16:creationId xmlns:a16="http://schemas.microsoft.com/office/drawing/2014/main" id="{8DA072A3-CFD2-C1F5-93D2-ECD8A65F2C99}"/>
+                </a:ext>
+              </a:extLst>
+            </p:cNvPr>
+            <p:cNvSpPr txBox="1"/>
+            <p:nvPr/>
+          </p:nvSpPr>
+          <p:spPr>
+            <a:xfrm>
+              <a:off x="1769984" y="1664374"/>
+              <a:ext cx="3893212" cy="369332"/>
+            </a:xfrm>
+            <a:prstGeom prst="rect">
+              <a:avLst/>
+            </a:prstGeom>
+            <a:noFill/>
+            <a:ln>
+              <a:solidFill>
+                <a:schemeClr val="bg1">
+                  <a:lumMod val="65000"/>
+                </a:schemeClr>
+              </a:solidFill>
+            </a:ln>
+          </p:spPr>
+          <p:txBody>
+            <a:bodyPr wrap="square" rtlCol="0">
+              <a:spAutoFit/>
+            </a:bodyPr>
+            <a:lstStyle/>
+            <a:p>
+              <a:pPr algn="ctr"/>
+              <a:r>
+                <a:rPr kumimoji="1" lang="en-US" altLang="ja-JP" dirty="0" err="1">
+                  <a:latin typeface="Consolas" panose="020B0609020204030204" pitchFamily="49" charset="0"/>
+                </a:rPr>
+                <a:t>ControllerManager</a:t>
+              </a:r>
+              <a:endParaRPr kumimoji="1" lang="ja-JP" altLang="en-US" dirty="0">
+                <a:latin typeface="Consolas" panose="020B0609020204030204" pitchFamily="49" charset="0"/>
+              </a:endParaRPr>
+            </a:p>
+          </p:txBody>
+        </p:sp>
+        <p:sp>
+          <p:nvSpPr>
+            <p:cNvPr id="20" name="テキスト ボックス 19">
+              <a:extLst>
+                <a:ext uri="{FF2B5EF4-FFF2-40B4-BE49-F238E27FC236}">
+                  <a16:creationId xmlns:a16="http://schemas.microsoft.com/office/drawing/2014/main" id="{F3A19FDF-62D2-F0F3-9FBC-A28F74E83592}"/>
+                </a:ext>
+              </a:extLst>
+            </p:cNvPr>
+            <p:cNvSpPr txBox="1"/>
+            <p:nvPr/>
+          </p:nvSpPr>
+          <p:spPr>
+            <a:xfrm flipH="1">
+              <a:off x="1460326" y="2883441"/>
+              <a:ext cx="4116403" cy="369332"/>
+            </a:xfrm>
+            <a:prstGeom prst="rect">
+              <a:avLst/>
+            </a:prstGeom>
+            <a:noFill/>
+          </p:spPr>
+          <p:txBody>
+            <a:bodyPr wrap="square" rtlCol="0">
+              <a:spAutoFit/>
+            </a:bodyPr>
+            <a:lstStyle/>
+            <a:p>
+              <a:r>
+                <a:rPr lang="en-US" altLang="ja-JP" dirty="0" err="1">
+                  <a:latin typeface="Consolas" panose="020B0609020204030204" pitchFamily="49" charset="0"/>
+                </a:rPr>
+                <a:t>LayeredHardware</a:t>
+              </a:r>
+              <a:endParaRPr kumimoji="1" lang="ja-JP" altLang="en-US" dirty="0">
+                <a:latin typeface="Consolas" panose="020B0609020204030204" pitchFamily="49" charset="0"/>
+              </a:endParaRPr>
+            </a:p>
+          </p:txBody>
+        </p:sp>
+        <p:cxnSp>
+          <p:nvCxnSpPr>
+            <p:cNvPr id="21" name="直線矢印コネクタ 20">
+              <a:extLst>
+                <a:ext uri="{FF2B5EF4-FFF2-40B4-BE49-F238E27FC236}">
+                  <a16:creationId xmlns:a16="http://schemas.microsoft.com/office/drawing/2014/main" id="{BD300D81-2899-4E82-AA82-BF9EB61125AB}"/>
+                </a:ext>
+              </a:extLst>
+            </p:cNvPr>
+            <p:cNvCxnSpPr>
+              <a:cxnSpLocks/>
+              <a:stCxn id="23" idx="2"/>
+            </p:cNvCxnSpPr>
+            <p:nvPr/>
+          </p:nvCxnSpPr>
+          <p:spPr>
+            <a:xfrm>
+              <a:off x="3716590" y="1488629"/>
+              <a:ext cx="3146" cy="1371548"/>
+            </a:xfrm>
+            <a:prstGeom prst="straightConnector1">
+              <a:avLst/>
+            </a:prstGeom>
+            <a:ln w="19050">
+              <a:solidFill>
+                <a:schemeClr val="tx1"/>
+              </a:solidFill>
+              <a:headEnd type="triangle" w="lg" len="med"/>
+              <a:tailEnd type="triangle" w="lg" len="med"/>
+            </a:ln>
+            <a:effectLst>
+              <a:glow rad="101600">
+                <a:schemeClr val="bg1">
+                  <a:alpha val="90000"/>
+                </a:schemeClr>
+              </a:glow>
+            </a:effectLst>
+          </p:spPr>
+          <p:style>
+            <a:lnRef idx="1">
+              <a:schemeClr val="accent1"/>
+            </a:lnRef>
+            <a:fillRef idx="0">
+              <a:schemeClr val="accent1"/>
+            </a:fillRef>
+            <a:effectRef idx="0">
+              <a:schemeClr val="accent1"/>
+            </a:effectRef>
+            <a:fontRef idx="minor">
+              <a:schemeClr val="tx1"/>
+            </a:fontRef>
+          </p:style>
+        </p:cxnSp>
+        <p:sp>
+          <p:nvSpPr>
+            <p:cNvPr id="22" name="テキスト ボックス 21">
+              <a:extLst>
+                <a:ext uri="{FF2B5EF4-FFF2-40B4-BE49-F238E27FC236}">
+                  <a16:creationId xmlns:a16="http://schemas.microsoft.com/office/drawing/2014/main" id="{0B8D8A0E-CBA6-585A-9D58-B69E6B9849CF}"/>
+                </a:ext>
+              </a:extLst>
+            </p:cNvPr>
+            <p:cNvSpPr txBox="1"/>
+            <p:nvPr/>
+          </p:nvSpPr>
+          <p:spPr>
+            <a:xfrm>
+              <a:off x="3719736" y="2532693"/>
+              <a:ext cx="759139" cy="307777"/>
+            </a:xfrm>
+            <a:prstGeom prst="rect">
+              <a:avLst/>
+            </a:prstGeom>
+            <a:noFill/>
+          </p:spPr>
+          <p:txBody>
+            <a:bodyPr wrap="square" rtlCol="0">
+              <a:spAutoFit/>
+            </a:bodyPr>
+            <a:lstStyle/>
+            <a:p>
+              <a:r>
+                <a:rPr kumimoji="1" lang="en-US" altLang="ja-JP" sz="1400" dirty="0">
+                  <a:latin typeface="Georgia" panose="02040502050405020303" pitchFamily="18" charset="0"/>
+                </a:rPr>
+                <a:t>update</a:t>
+              </a:r>
+              <a:endParaRPr kumimoji="1" lang="ja-JP" altLang="en-US" sz="1400" dirty="0">
+                <a:latin typeface="Georgia" panose="02040502050405020303" pitchFamily="18" charset="0"/>
+              </a:endParaRPr>
+            </a:p>
+          </p:txBody>
+        </p:sp>
+        <p:sp>
+          <p:nvSpPr>
+            <p:cNvPr id="23" name="テキスト ボックス 22">
+              <a:extLst>
+                <a:ext uri="{FF2B5EF4-FFF2-40B4-BE49-F238E27FC236}">
+                  <a16:creationId xmlns:a16="http://schemas.microsoft.com/office/drawing/2014/main" id="{05E929F3-97CC-512F-69C7-B08F89CE7A5D}"/>
+                </a:ext>
+              </a:extLst>
+            </p:cNvPr>
+            <p:cNvSpPr txBox="1"/>
+            <p:nvPr/>
+          </p:nvSpPr>
+          <p:spPr>
+            <a:xfrm>
+              <a:off x="1769984" y="1119297"/>
+              <a:ext cx="3893212" cy="369332"/>
+            </a:xfrm>
+            <a:prstGeom prst="rect">
+              <a:avLst/>
+            </a:prstGeom>
+            <a:noFill/>
+            <a:ln>
+              <a:solidFill>
+                <a:schemeClr val="bg1">
+                  <a:lumMod val="65000"/>
+                </a:schemeClr>
+              </a:solidFill>
+            </a:ln>
+          </p:spPr>
+          <p:txBody>
+            <a:bodyPr wrap="square" rtlCol="0">
+              <a:spAutoFit/>
+            </a:bodyPr>
+            <a:lstStyle/>
+            <a:p>
+              <a:pPr algn="ctr"/>
+              <a:r>
+                <a:rPr kumimoji="1" lang="en-US" altLang="ja-JP" dirty="0">
+                  <a:latin typeface="Consolas" panose="020B0609020204030204" pitchFamily="49" charset="0"/>
+                </a:rPr>
+                <a:t>Controllers</a:t>
+              </a:r>
+              <a:endParaRPr kumimoji="1" lang="ja-JP" altLang="en-US" dirty="0">
+                <a:latin typeface="Consolas" panose="020B0609020204030204" pitchFamily="49" charset="0"/>
+              </a:endParaRPr>
+            </a:p>
+          </p:txBody>
+        </p:sp>
+        <p:sp>
+          <p:nvSpPr>
+            <p:cNvPr id="24" name="正方形/長方形 23">
+              <a:extLst>
+                <a:ext uri="{FF2B5EF4-FFF2-40B4-BE49-F238E27FC236}">
+                  <a16:creationId xmlns:a16="http://schemas.microsoft.com/office/drawing/2014/main" id="{0184FEE4-83C5-9B9D-7535-3824ED1E95B3}"/>
+                </a:ext>
+              </a:extLst>
+            </p:cNvPr>
+            <p:cNvSpPr/>
+            <p:nvPr/>
+          </p:nvSpPr>
+          <p:spPr>
+            <a:xfrm>
+              <a:off x="1375516" y="2860176"/>
+              <a:ext cx="4638844" cy="2912877"/>
+            </a:xfrm>
+            <a:prstGeom prst="rect">
+              <a:avLst/>
+            </a:prstGeom>
+            <a:noFill/>
+            <a:ln w="19050">
+              <a:solidFill>
+                <a:schemeClr val="tx1"/>
+              </a:solidFill>
+            </a:ln>
+          </p:spPr>
+          <p:style>
+            <a:lnRef idx="2">
+              <a:schemeClr val="accent1">
+                <a:shade val="50000"/>
+              </a:schemeClr>
+            </a:lnRef>
+            <a:fillRef idx="1">
+              <a:schemeClr val="accent1"/>
+            </a:fillRef>
+            <a:effectRef idx="0">
+              <a:schemeClr val="accent1"/>
+            </a:effectRef>
+            <a:fontRef idx="minor">
+              <a:schemeClr val="lt1"/>
+            </a:fontRef>
+          </p:style>
+          <p:txBody>
+            <a:bodyPr rtlCol="0" anchor="ctr"/>
+            <a:lstStyle/>
+            <a:p>
+              <a:pPr algn="ctr"/>
+              <a:endParaRPr kumimoji="1" lang="ja-JP" altLang="en-US"/>
+            </a:p>
+          </p:txBody>
+        </p:sp>
+        <p:sp>
+          <p:nvSpPr>
+            <p:cNvPr id="25" name="テキスト ボックス 24">
+              <a:extLst>
+                <a:ext uri="{FF2B5EF4-FFF2-40B4-BE49-F238E27FC236}">
+                  <a16:creationId xmlns:a16="http://schemas.microsoft.com/office/drawing/2014/main" id="{E59EC628-A94B-2348-6352-345A2DBA5F60}"/>
+                </a:ext>
+              </a:extLst>
+            </p:cNvPr>
+            <p:cNvSpPr txBox="1"/>
+            <p:nvPr/>
+          </p:nvSpPr>
+          <p:spPr>
+            <a:xfrm>
+              <a:off x="4328749" y="3881100"/>
+              <a:ext cx="680816" cy="307777"/>
+            </a:xfrm>
+            <a:prstGeom prst="rect">
+              <a:avLst/>
+            </a:prstGeom>
+            <a:noFill/>
+          </p:spPr>
+          <p:txBody>
+            <a:bodyPr wrap="square" rtlCol="0">
+              <a:spAutoFit/>
+            </a:bodyPr>
+            <a:lstStyle/>
+            <a:p>
+              <a:r>
+                <a:rPr kumimoji="1" lang="en-US" altLang="ja-JP" sz="1400" dirty="0">
+                  <a:latin typeface="Georgia" panose="02040502050405020303" pitchFamily="18" charset="0"/>
+                </a:rPr>
+                <a:t>write</a:t>
+              </a:r>
+              <a:endParaRPr kumimoji="1" lang="ja-JP" altLang="en-US" sz="1400" dirty="0">
+                <a:latin typeface="Georgia" panose="02040502050405020303" pitchFamily="18" charset="0"/>
+              </a:endParaRPr>
+            </a:p>
+          </p:txBody>
+        </p:sp>
+        <p:sp>
+          <p:nvSpPr>
+            <p:cNvPr id="26" name="テキスト ボックス 25">
+              <a:extLst>
+                <a:ext uri="{FF2B5EF4-FFF2-40B4-BE49-F238E27FC236}">
+                  <a16:creationId xmlns:a16="http://schemas.microsoft.com/office/drawing/2014/main" id="{D8C90346-2C0B-C2ED-81F8-A88393972F3B}"/>
+                </a:ext>
+              </a:extLst>
+            </p:cNvPr>
+            <p:cNvSpPr txBox="1"/>
+            <p:nvPr/>
+          </p:nvSpPr>
+          <p:spPr>
+            <a:xfrm>
+              <a:off x="3113290" y="3876248"/>
+              <a:ext cx="680816" cy="307777"/>
+            </a:xfrm>
+            <a:prstGeom prst="rect">
+              <a:avLst/>
+            </a:prstGeom>
+            <a:noFill/>
+          </p:spPr>
+          <p:txBody>
+            <a:bodyPr wrap="square" rtlCol="0">
+              <a:spAutoFit/>
+            </a:bodyPr>
+            <a:lstStyle/>
+            <a:p>
+              <a:r>
+                <a:rPr lang="en-US" altLang="ja-JP" sz="1400" dirty="0">
+                  <a:latin typeface="Georgia" panose="02040502050405020303" pitchFamily="18" charset="0"/>
+                </a:rPr>
+                <a:t>r</a:t>
+              </a:r>
+              <a:r>
+                <a:rPr kumimoji="1" lang="en-US" altLang="ja-JP" sz="1400" dirty="0">
+                  <a:latin typeface="Georgia" panose="02040502050405020303" pitchFamily="18" charset="0"/>
+                </a:rPr>
+                <a:t>ead</a:t>
+              </a:r>
+              <a:endParaRPr kumimoji="1" lang="ja-JP" altLang="en-US" sz="1400" dirty="0">
+                <a:latin typeface="Georgia" panose="02040502050405020303" pitchFamily="18" charset="0"/>
+              </a:endParaRPr>
+            </a:p>
+          </p:txBody>
+        </p:sp>
+        <p:cxnSp>
+          <p:nvCxnSpPr>
+            <p:cNvPr id="29" name="直線矢印コネクタ 28">
+              <a:extLst>
+                <a:ext uri="{FF2B5EF4-FFF2-40B4-BE49-F238E27FC236}">
+                  <a16:creationId xmlns:a16="http://schemas.microsoft.com/office/drawing/2014/main" id="{98DEEBB4-3560-A057-18D9-730526EA4DCF}"/>
+                </a:ext>
+              </a:extLst>
+            </p:cNvPr>
+            <p:cNvCxnSpPr>
+              <a:cxnSpLocks/>
+            </p:cNvCxnSpPr>
+            <p:nvPr/>
+          </p:nvCxnSpPr>
+          <p:spPr>
+            <a:xfrm flipH="1" flipV="1">
+              <a:off x="5663196" y="1849040"/>
+              <a:ext cx="2737060" cy="1800"/>
+            </a:xfrm>
+            <a:prstGeom prst="straightConnector1">
+              <a:avLst/>
+            </a:prstGeom>
+            <a:ln w="19050">
+              <a:solidFill>
+                <a:schemeClr val="tx1"/>
+              </a:solidFill>
+              <a:tailEnd type="triangle" w="lg" len="med"/>
+            </a:ln>
+          </p:spPr>
+          <p:style>
+            <a:lnRef idx="1">
+              <a:schemeClr val="accent1"/>
+            </a:lnRef>
+            <a:fillRef idx="0">
+              <a:schemeClr val="accent1"/>
+            </a:fillRef>
+            <a:effectRef idx="0">
+              <a:schemeClr val="accent1"/>
+            </a:effectRef>
+            <a:fontRef idx="minor">
+              <a:schemeClr val="tx1"/>
+            </a:fontRef>
+          </p:style>
+        </p:cxnSp>
+        <p:cxnSp>
+          <p:nvCxnSpPr>
+            <p:cNvPr id="30" name="直線矢印コネクタ 29">
+              <a:extLst>
+                <a:ext uri="{FF2B5EF4-FFF2-40B4-BE49-F238E27FC236}">
+                  <a16:creationId xmlns:a16="http://schemas.microsoft.com/office/drawing/2014/main" id="{611B9285-3B80-1878-5FCE-5E75D42CAFB1}"/>
+                </a:ext>
+              </a:extLst>
+            </p:cNvPr>
+            <p:cNvCxnSpPr>
+              <a:cxnSpLocks/>
+            </p:cNvCxnSpPr>
+            <p:nvPr/>
+          </p:nvCxnSpPr>
+          <p:spPr>
+            <a:xfrm flipV="1">
+              <a:off x="8400256" y="1488629"/>
+              <a:ext cx="0" cy="362177"/>
+            </a:xfrm>
+            <a:prstGeom prst="straightConnector1">
+              <a:avLst/>
+            </a:prstGeom>
+            <a:ln w="19050">
+              <a:solidFill>
+                <a:schemeClr val="tx1"/>
+              </a:solidFill>
+              <a:tailEnd type="none" w="lg" len="med"/>
+            </a:ln>
+          </p:spPr>
+          <p:style>
+            <a:lnRef idx="1">
+              <a:schemeClr val="accent1"/>
+            </a:lnRef>
+            <a:fillRef idx="0">
+              <a:schemeClr val="accent1"/>
+            </a:fillRef>
+            <a:effectRef idx="0">
+              <a:schemeClr val="accent1"/>
+            </a:effectRef>
+            <a:fontRef idx="minor">
+              <a:schemeClr val="tx1"/>
+            </a:fontRef>
+          </p:style>
+        </p:cxnSp>
+        <p:sp>
+          <p:nvSpPr>
+            <p:cNvPr id="31" name="テキスト ボックス 30">
+              <a:extLst>
+                <a:ext uri="{FF2B5EF4-FFF2-40B4-BE49-F238E27FC236}">
+                  <a16:creationId xmlns:a16="http://schemas.microsoft.com/office/drawing/2014/main" id="{26777C61-F642-11DE-80EF-5BCBCC8F2FE4}"/>
+                </a:ext>
+              </a:extLst>
+            </p:cNvPr>
+            <p:cNvSpPr txBox="1"/>
+            <p:nvPr/>
+          </p:nvSpPr>
+          <p:spPr>
+            <a:xfrm>
+              <a:off x="6425876" y="1859493"/>
+              <a:ext cx="2118396" cy="523220"/>
+            </a:xfrm>
+            <a:prstGeom prst="rect">
+              <a:avLst/>
+            </a:prstGeom>
+            <a:noFill/>
+          </p:spPr>
+          <p:txBody>
+            <a:bodyPr wrap="square" rtlCol="0">
+              <a:spAutoFit/>
+            </a:bodyPr>
+            <a:lstStyle/>
+            <a:p>
+              <a:r>
+                <a:rPr lang="en-US" altLang="ja-JP" sz="1400" dirty="0">
+                  <a:latin typeface="Georgia" panose="02040502050405020303" pitchFamily="18" charset="0"/>
+                </a:rPr>
+                <a:t>a</a:t>
+              </a:r>
+              <a:r>
+                <a:rPr kumimoji="1" lang="en-US" altLang="ja-JP" sz="1400" dirty="0">
+                  <a:latin typeface="Georgia" panose="02040502050405020303" pitchFamily="18" charset="0"/>
+                </a:rPr>
+                <a:t>sk controller switching</a:t>
+              </a:r>
+              <a:br>
+                <a:rPr kumimoji="1" lang="en-US" altLang="ja-JP" sz="1400" dirty="0">
+                  <a:latin typeface="Georgia" panose="02040502050405020303" pitchFamily="18" charset="0"/>
+                </a:rPr>
+              </a:br>
+              <a:r>
+                <a:rPr kumimoji="1" lang="en-US" altLang="ja-JP" sz="1400" dirty="0">
+                  <a:latin typeface="Georgia" panose="02040502050405020303" pitchFamily="18" charset="0"/>
+                </a:rPr>
+                <a:t>via ROS </a:t>
+              </a:r>
+              <a:r>
+                <a:rPr lang="en-US" altLang="ja-JP" sz="1400" dirty="0">
+                  <a:latin typeface="Georgia" panose="02040502050405020303" pitchFamily="18" charset="0"/>
+                </a:rPr>
+                <a:t>service</a:t>
+              </a:r>
+              <a:r>
+                <a:rPr kumimoji="1" lang="en-US" altLang="ja-JP" sz="1400" dirty="0">
+                  <a:latin typeface="Georgia" panose="02040502050405020303" pitchFamily="18" charset="0"/>
+                </a:rPr>
+                <a:t>s</a:t>
+              </a:r>
+              <a:endParaRPr kumimoji="1" lang="ja-JP" altLang="en-US" sz="1400" dirty="0">
+                <a:latin typeface="Georgia" panose="02040502050405020303" pitchFamily="18" charset="0"/>
+              </a:endParaRPr>
+            </a:p>
+          </p:txBody>
+        </p:sp>
+      </p:grpSp>
+    </p:spTree>
+    <p:extLst>
+      <p:ext uri="{BB962C8B-B14F-4D97-AF65-F5344CB8AC3E}">
+        <p14:creationId xmlns:p14="http://schemas.microsoft.com/office/powerpoint/2010/main" val="1018227043"/>
+      </p:ext>
+    </p:extLst>
+  </p:cSld>
+  <p:clrMapOvr>
+    <a:masterClrMapping/>
+  </p:clrMapOvr>
+</p:sld>
+</file>
+
 <file path=ppt/theme/theme1.xml><?xml version="1.0" encoding="utf-8"?>
 <a:theme xmlns:a="http://schemas.openxmlformats.org/drawingml/2006/main" name="Office テーマ">
   <a:themeElements>

</xml_diff>